<commit_message>
refactor(presentation): redesign slides 6 & 7 with clean benchmark and MLOps CI/CD/CT achievements
</commit_message>
<xml_diff>
--- a/Bloc_6_CliNER/CliNER_presentation.pptx
+++ b/Bloc_6_CliNER/CliNER_presentation.pptx
@@ -12940,597 +12940,588 @@
       </p:grpSpPr>
       <p:sp>
         <p:nvSpPr>
-          <p:cNvPr id="123" name="Google Shape;123;p8"/>
+          <p:cNvPr id="123" name="Rectangle 122"/>
+          <p:cNvSpPr/>
+          <p:nvPr/>
+        </p:nvSpPr>
+        <p:spPr>
+          <a:xfrm>
+            <a:off x="0" y="0"/>
+            <a:ext cx="12191675" cy="6858000"/>
+          </a:xfrm>
+          <a:prstGeom prst="rect">
+            <a:avLst/>
+          </a:prstGeom>
+          <a:solidFill>
+            <a:srgbClr val="0A1420"/>
+          </a:solidFill>
+          <a:ln>
+            <a:noFill/>
+          </a:ln>
+        </p:spPr>
+        <p:style>
+          <a:lnRef idx="1">
+            <a:schemeClr val="accent1"/>
+          </a:lnRef>
+          <a:fillRef idx="3">
+            <a:schemeClr val="accent1"/>
+          </a:fillRef>
+          <a:effectRef idx="2">
+            <a:schemeClr val="accent1"/>
+          </a:effectRef>
+          <a:fontRef idx="minor">
+            <a:schemeClr val="lt1"/>
+          </a:fontRef>
+        </p:style>
+        <p:txBody>
+          <a:bodyPr rtlCol="0" anchor="ctr"/>
+          <a:lstStyle/>
+          <a:p>
+            <a:pPr algn="ctr"/>
+          </a:p>
+        </p:txBody>
+      </p:sp>
+      <p:sp>
+        <p:nvSpPr>
+          <p:cNvPr id="124" name="TextBox 123"/>
           <p:cNvSpPr txBox="1"/>
           <p:nvPr/>
         </p:nvSpPr>
         <p:spPr>
           <a:xfrm>
-            <a:off x="1245078" y="317385"/>
-            <a:ext cx="10728600" cy="585000"/>
+            <a:off x="731520" y="365760"/>
+            <a:ext cx="10515600" cy="731520"/>
           </a:xfrm>
           <a:prstGeom prst="rect">
             <a:avLst/>
           </a:prstGeom>
           <a:noFill/>
-          <a:ln>
-            <a:noFill/>
-          </a:ln>
         </p:spPr>
         <p:txBody>
-          <a:bodyPr anchorCtr="0" anchor="t" bIns="45700" lIns="91425" spcFirstLastPara="1" rIns="91425" wrap="square" tIns="45700">
+          <a:bodyPr wrap="square">
             <a:spAutoFit/>
           </a:bodyPr>
           <a:lstStyle/>
           <a:p>
-            <a:pPr indent="457200" lvl="0" marL="2743200" marR="0" rtl="0" algn="l">
-              <a:spcBef>
-                <a:spcPts val="0"/>
-              </a:spcBef>
-              <a:spcAft>
-                <a:spcPts val="0"/>
-              </a:spcAft>
-              <a:buNone/>
+            <a:pPr>
+              <a:defRPr sz="2600" b="1">
+                <a:solidFill>
+                  <a:srgbClr val="22D3EE"/>
+                </a:solidFill>
+              </a:defRPr>
             </a:pPr>
             <a:r>
-              <a:rPr b="1" lang="en-US" sz="3200">
+              <a:t>BENCHMARK DE PERFORMANCE NER</a:t>
+            </a:r>
+          </a:p>
+          <a:p>
+            <a:pPr>
+              <a:spcBef>
+                <a:spcPts val="300"/>
+              </a:spcBef>
+              <a:defRPr sz="1300">
                 <a:solidFill>
-                  <a:srgbClr val="00D2FF"/>
+                  <a:srgbClr val="94A3B8"/>
                 </a:solidFill>
-                <a:latin typeface="Calibri"/>
-                <a:ea typeface="Calibri"/>
-                <a:cs typeface="Calibri"/>
-                <a:sym typeface="Calibri"/>
-              </a:rPr>
-              <a:t>BENCHMARK</a:t>
+              </a:defRPr>
+            </a:pPr>
+            <a:r>
+              <a:t>Évaluation comparative sur le Gold Standard CHIA (Dataset Médical d'Éligibilité)</a:t>
             </a:r>
-            <a:endParaRPr/>
           </a:p>
         </p:txBody>
       </p:sp>
       <p:graphicFrame>
         <p:nvGraphicFramePr>
-          <p:cNvPr id="124" name="Google Shape;124;p8"/>
-          <p:cNvGraphicFramePr/>
+          <p:cNvPr id="125" name="Table 124"/>
+          <p:cNvGraphicFramePr>
+            <a:graphicFrameLocks noGrp="1"/>
+          </p:cNvGraphicFramePr>
           <p:nvPr/>
         </p:nvGraphicFramePr>
         <p:xfrm>
-          <a:off x="3534715" y="1809400"/>
-          <a:ext cx="3000000" cy="3000000"/>
+          <a:off x="731520" y="1371600"/>
+          <a:ext cx="10698480" cy="2011680"/>
         </p:xfrm>
         <a:graphic>
           <a:graphicData uri="http://schemas.openxmlformats.org/drawingml/2006/table">
             <a:tbl>
-              <a:tblPr>
-                <a:noFill/>
-                <a:tableStyleId>{56A1C287-B342-465F-B4A4-0F307ADDF34E}</a:tableStyleId>
+              <a:tblPr firstRow="1" bandRow="1">
+                <a:tableStyleId>{5C22544A-7EE6-4342-B048-85BDC9FD1C3A}</a:tableStyleId>
               </a:tblPr>
               <a:tblGrid>
-                <a:gridCol w="2404250"/>
-                <a:gridCol w="1361350"/>
-                <a:gridCol w="1278000"/>
-                <a:gridCol w="1105725"/>
+                <a:gridCol w="3291840"/>
+                <a:gridCol w="1645920"/>
+                <a:gridCol w="1645920"/>
+                <a:gridCol w="1645920"/>
+                <a:gridCol w="2468880"/>
               </a:tblGrid>
-              <a:tr h="381000">
+              <a:tr h="502920">
                 <a:tc>
                   <a:txBody>
                     <a:bodyPr/>
                     <a:lstStyle/>
                     <a:p>
-                      <a:pPr indent="0" lvl="0" marL="0" rtl="0" algn="l">
-                        <a:spcBef>
-                          <a:spcPts val="0"/>
-                        </a:spcBef>
-                        <a:spcAft>
-                          <a:spcPts val="0"/>
-                        </a:spcAft>
-                        <a:buNone/>
+                      <a:pPr algn="l">
+                        <a:defRPr b="1" sz="1100">
+                          <a:solidFill>
+                            <a:srgbClr val="22D3EE"/>
+                          </a:solidFill>
+                        </a:defRPr>
                       </a:pPr>
                       <a:r>
-                        <a:rPr lang="en-US">
-                          <a:solidFill>
-                            <a:schemeClr val="lt1"/>
-                          </a:solidFill>
-                        </a:rPr>
-                        <a:t>MODELS</a:t>
+                        <a:t>MODÈLE ÉVALUÉ</a:t>
                       </a:r>
-                      <a:endParaRPr>
-                        <a:solidFill>
-                          <a:schemeClr val="lt1"/>
-                        </a:solidFill>
-                      </a:endParaRPr>
                     </a:p>
                   </a:txBody>
-                  <a:tcPr marT="91425" marB="91425" marR="91425" marL="91425"/>
+                  <a:tcPr>
+                    <a:solidFill>
+                      <a:srgbClr val="103750"/>
+                    </a:solidFill>
+                  </a:tcPr>
                 </a:tc>
                 <a:tc>
                   <a:txBody>
                     <a:bodyPr/>
                     <a:lstStyle/>
                     <a:p>
-                      <a:pPr indent="0" lvl="0" marL="0" rtl="0" algn="l">
-                        <a:spcBef>
-                          <a:spcPts val="0"/>
-                        </a:spcBef>
-                        <a:spcAft>
-                          <a:spcPts val="0"/>
-                        </a:spcAft>
-                        <a:buNone/>
+                      <a:pPr algn="ctr">
+                        <a:defRPr b="1" sz="1100">
+                          <a:solidFill>
+                            <a:srgbClr val="22D3EE"/>
+                          </a:solidFill>
+                        </a:defRPr>
                       </a:pPr>
                       <a:r>
-                        <a:rPr lang="en-US">
-                          <a:solidFill>
-                            <a:schemeClr val="lt1"/>
-                          </a:solidFill>
-                        </a:rPr>
-                        <a:t>précision</a:t>
+                        <a:t>PRÉCISION</a:t>
                       </a:r>
-                      <a:endParaRPr>
-                        <a:solidFill>
-                          <a:schemeClr val="lt1"/>
-                        </a:solidFill>
-                      </a:endParaRPr>
                     </a:p>
                   </a:txBody>
-                  <a:tcPr marT="91425" marB="91425" marR="91425" marL="91425"/>
+                  <a:tcPr>
+                    <a:solidFill>
+                      <a:srgbClr val="103750"/>
+                    </a:solidFill>
+                  </a:tcPr>
                 </a:tc>
                 <a:tc>
                   <a:txBody>
                     <a:bodyPr/>
                     <a:lstStyle/>
                     <a:p>
-                      <a:pPr indent="0" lvl="0" marL="0" rtl="0" algn="l">
-                        <a:spcBef>
-                          <a:spcPts val="0"/>
-                        </a:spcBef>
-                        <a:spcAft>
-                          <a:spcPts val="0"/>
-                        </a:spcAft>
-                        <a:buNone/>
+                      <a:pPr algn="ctr">
+                        <a:defRPr b="1" sz="1100">
+                          <a:solidFill>
+                            <a:srgbClr val="22D3EE"/>
+                          </a:solidFill>
+                        </a:defRPr>
                       </a:pPr>
                       <a:r>
-                        <a:rPr lang="en-US">
-                          <a:solidFill>
-                            <a:schemeClr val="lt1"/>
-                          </a:solidFill>
-                        </a:rPr>
-                        <a:t>recall</a:t>
+                        <a:t>RAPPEL</a:t>
                       </a:r>
-                      <a:endParaRPr>
-                        <a:solidFill>
-                          <a:schemeClr val="lt1"/>
-                        </a:solidFill>
-                      </a:endParaRPr>
                     </a:p>
                   </a:txBody>
-                  <a:tcPr marT="91425" marB="91425" marR="91425" marL="91425"/>
+                  <a:tcPr>
+                    <a:solidFill>
+                      <a:srgbClr val="103750"/>
+                    </a:solidFill>
+                  </a:tcPr>
                 </a:tc>
                 <a:tc>
                   <a:txBody>
                     <a:bodyPr/>
                     <a:lstStyle/>
                     <a:p>
-                      <a:pPr indent="0" lvl="0" marL="0" rtl="0" algn="l">
-                        <a:spcBef>
-                          <a:spcPts val="0"/>
-                        </a:spcBef>
-                        <a:spcAft>
-                          <a:spcPts val="0"/>
-                        </a:spcAft>
-                        <a:buNone/>
+                      <a:pPr algn="ctr">
+                        <a:defRPr b="1" sz="1100">
+                          <a:solidFill>
+                            <a:srgbClr val="22D3EE"/>
+                          </a:solidFill>
+                        </a:defRPr>
                       </a:pPr>
                       <a:r>
-                        <a:rPr lang="en-US">
-                          <a:solidFill>
-                            <a:schemeClr val="lt1"/>
-                          </a:solidFill>
-                        </a:rPr>
-                        <a:t>F1</a:t>
+                        <a:t>SCORE F1</a:t>
                       </a:r>
-                      <a:endParaRPr>
-                        <a:solidFill>
-                          <a:schemeClr val="lt1"/>
-                        </a:solidFill>
-                      </a:endParaRPr>
                     </a:p>
                   </a:txBody>
-                  <a:tcPr marT="91425" marB="91425" marR="91425" marL="91425"/>
-                </a:tc>
-              </a:tr>
-              <a:tr h="366425">
-                <a:tc>
-                  <a:txBody>
-                    <a:bodyPr/>
-                    <a:lstStyle/>
-                    <a:p>
-                      <a:pPr indent="0" lvl="0" marL="0" rtl="0" algn="l">
-                        <a:spcBef>
-                          <a:spcPts val="0"/>
-                        </a:spcBef>
-                        <a:spcAft>
-                          <a:spcPts val="0"/>
-                        </a:spcAft>
-                        <a:buNone/>
-                      </a:pPr>
-                      <a:r>
-                        <a:rPr lang="en-US">
-                          <a:solidFill>
-                            <a:schemeClr val="lt1"/>
-                          </a:solidFill>
-                        </a:rPr>
-                        <a:t>dictionary</a:t>
-                      </a:r>
-                      <a:r>
-                        <a:rPr lang="en-US">
-                          <a:solidFill>
-                            <a:schemeClr val="lt1"/>
-                          </a:solidFill>
-                        </a:rPr>
-                        <a:t> floor</a:t>
-                      </a:r>
-                      <a:endParaRPr>
-                        <a:solidFill>
-                          <a:schemeClr val="lt1"/>
-                        </a:solidFill>
-                      </a:endParaRPr>
-                    </a:p>
-                  </a:txBody>
-                  <a:tcPr marT="91425" marB="91425" marR="91425" marL="91425"/>
+                  <a:tcPr>
+                    <a:solidFill>
+                      <a:srgbClr val="103750"/>
+                    </a:solidFill>
+                  </a:tcPr>
                 </a:tc>
                 <a:tc>
                   <a:txBody>
                     <a:bodyPr/>
                     <a:lstStyle/>
                     <a:p>
-                      <a:pPr indent="0" lvl="0" marL="0" rtl="0" algn="l">
-                        <a:spcBef>
-                          <a:spcPts val="0"/>
-                        </a:spcBef>
-                        <a:spcAft>
-                          <a:spcPts val="0"/>
-                        </a:spcAft>
-                        <a:buNone/>
+                      <a:pPr algn="ctr">
+                        <a:defRPr b="1" sz="1100">
+                          <a:solidFill>
+                            <a:srgbClr val="22D3EE"/>
+                          </a:solidFill>
+                        </a:defRPr>
                       </a:pPr>
                       <a:r>
-                        <a:rPr lang="en-US">
-                          <a:solidFill>
-                            <a:schemeClr val="lt1"/>
-                          </a:solidFill>
-                        </a:rPr>
-                        <a:t>0.27</a:t>
+                        <a:t>GAIN OPÉRATIONNEL</a:t>
                       </a:r>
-                      <a:endParaRPr>
-                        <a:solidFill>
-                          <a:schemeClr val="lt1"/>
-                        </a:solidFill>
-                      </a:endParaRPr>
                     </a:p>
                   </a:txBody>
-                  <a:tcPr marT="91425" marB="91425" marR="91425" marL="91425"/>
+                  <a:tcPr>
+                    <a:solidFill>
+                      <a:srgbClr val="103750"/>
+                    </a:solidFill>
+                  </a:tcPr>
+                </a:tc>
+              </a:tr>
+              <a:tr h="502920">
+                <a:tc>
+                  <a:txBody>
+                    <a:bodyPr/>
+                    <a:lstStyle/>
+                    <a:p>
+                      <a:pPr algn="l">
+                        <a:defRPr sz="1050" b="1">
+                          <a:solidFill>
+                            <a:srgbClr val="F8FAFC"/>
+                          </a:solidFill>
+                        </a:defRPr>
+                      </a:pPr>
+                      <a:r>
+                        <a:t>Dictionary Floor (Règles &amp; Lexique)</a:t>
+                      </a:r>
+                    </a:p>
+                  </a:txBody>
+                  <a:tcPr>
+                    <a:solidFill>
+                      <a:srgbClr val="0E2334"/>
+                    </a:solidFill>
+                  </a:tcPr>
                 </a:tc>
                 <a:tc>
                   <a:txBody>
                     <a:bodyPr/>
                     <a:lstStyle/>
                     <a:p>
-                      <a:pPr indent="0" lvl="0" marL="0" rtl="0" algn="l">
-                        <a:spcBef>
-                          <a:spcPts val="0"/>
-                        </a:spcBef>
-                        <a:spcAft>
-                          <a:spcPts val="0"/>
-                        </a:spcAft>
-                        <a:buNone/>
+                      <a:pPr algn="ctr">
+                        <a:defRPr sz="1050" b="0">
+                          <a:solidFill>
+                            <a:srgbClr val="F8FAFC"/>
+                          </a:solidFill>
+                        </a:defRPr>
                       </a:pPr>
                       <a:r>
-                        <a:rPr lang="en-US">
-                          <a:solidFill>
-                            <a:schemeClr val="lt1"/>
-                          </a:solidFill>
-                        </a:rPr>
-                        <a:t>0.36</a:t>
+                        <a:t>27,0 %</a:t>
                       </a:r>
-                      <a:endParaRPr>
-                        <a:solidFill>
-                          <a:schemeClr val="lt1"/>
-                        </a:solidFill>
-                      </a:endParaRPr>
                     </a:p>
                   </a:txBody>
-                  <a:tcPr marT="91425" marB="91425" marR="91425" marL="91425"/>
+                  <a:tcPr>
+                    <a:solidFill>
+                      <a:srgbClr val="0E2334"/>
+                    </a:solidFill>
+                  </a:tcPr>
                 </a:tc>
                 <a:tc>
                   <a:txBody>
                     <a:bodyPr/>
                     <a:lstStyle/>
                     <a:p>
-                      <a:pPr indent="0" lvl="0" marL="0" rtl="0" algn="l">
-                        <a:spcBef>
-                          <a:spcPts val="0"/>
-                        </a:spcBef>
-                        <a:spcAft>
-                          <a:spcPts val="0"/>
-                        </a:spcAft>
-                        <a:buNone/>
+                      <a:pPr algn="ctr">
+                        <a:defRPr sz="1050" b="0">
+                          <a:solidFill>
+                            <a:srgbClr val="F8FAFC"/>
+                          </a:solidFill>
+                        </a:defRPr>
                       </a:pPr>
                       <a:r>
-                        <a:rPr lang="en-US">
-                          <a:solidFill>
-                            <a:schemeClr val="lt1"/>
-                          </a:solidFill>
-                        </a:rPr>
-                        <a:t>0.31</a:t>
+                        <a:t>36,0 %</a:t>
                       </a:r>
-                      <a:endParaRPr>
-                        <a:solidFill>
-                          <a:schemeClr val="lt1"/>
-                        </a:solidFill>
-                      </a:endParaRPr>
                     </a:p>
                   </a:txBody>
-                  <a:tcPr marT="91425" marB="91425" marR="91425" marL="91425"/>
-                </a:tc>
-              </a:tr>
-              <a:tr h="381000">
-                <a:tc>
-                  <a:txBody>
-                    <a:bodyPr/>
-                    <a:lstStyle/>
-                    <a:p>
-                      <a:pPr indent="0" lvl="0" marL="0" rtl="0" algn="l">
-                        <a:spcBef>
-                          <a:spcPts val="0"/>
-                        </a:spcBef>
-                        <a:spcAft>
-                          <a:spcPts val="0"/>
-                        </a:spcAft>
-                        <a:buNone/>
-                      </a:pPr>
-                      <a:r>
-                        <a:rPr lang="en-US">
-                          <a:solidFill>
-                            <a:schemeClr val="lt1"/>
-                          </a:solidFill>
-                        </a:rPr>
-                        <a:t>Qwen8B </a:t>
-                      </a:r>
-                      <a:endParaRPr>
-                        <a:solidFill>
-                          <a:schemeClr val="lt1"/>
-                        </a:solidFill>
-                      </a:endParaRPr>
-                    </a:p>
-                  </a:txBody>
-                  <a:tcPr marT="91425" marB="91425" marR="91425" marL="91425"/>
+                  <a:tcPr>
+                    <a:solidFill>
+                      <a:srgbClr val="0E2334"/>
+                    </a:solidFill>
+                  </a:tcPr>
                 </a:tc>
                 <a:tc>
                   <a:txBody>
                     <a:bodyPr/>
                     <a:lstStyle/>
                     <a:p>
-                      <a:pPr indent="0" lvl="0" marL="0" rtl="0" algn="l">
-                        <a:spcBef>
-                          <a:spcPts val="0"/>
-                        </a:spcBef>
-                        <a:spcAft>
-                          <a:spcPts val="0"/>
-                        </a:spcAft>
-                        <a:buNone/>
+                      <a:pPr algn="ctr">
+                        <a:defRPr sz="1050" b="0">
+                          <a:solidFill>
+                            <a:srgbClr val="F8FAFC"/>
+                          </a:solidFill>
+                        </a:defRPr>
                       </a:pPr>
                       <a:r>
-                        <a:rPr lang="en-US">
-                          <a:solidFill>
-                            <a:schemeClr val="lt1"/>
-                          </a:solidFill>
-                        </a:rPr>
-                        <a:t>0.44</a:t>
+                        <a:t>0,31</a:t>
                       </a:r>
-                      <a:endParaRPr>
-                        <a:solidFill>
-                          <a:schemeClr val="lt1"/>
-                        </a:solidFill>
-                      </a:endParaRPr>
                     </a:p>
                   </a:txBody>
-                  <a:tcPr marT="91425" marB="91425" marR="91425" marL="91425"/>
+                  <a:tcPr>
+                    <a:solidFill>
+                      <a:srgbClr val="0E2334"/>
+                    </a:solidFill>
+                  </a:tcPr>
                 </a:tc>
                 <a:tc>
                   <a:txBody>
                     <a:bodyPr/>
                     <a:lstStyle/>
                     <a:p>
-                      <a:pPr indent="0" lvl="0" marL="0" rtl="0" algn="l">
-                        <a:spcBef>
-                          <a:spcPts val="0"/>
-                        </a:spcBef>
-                        <a:spcAft>
-                          <a:spcPts val="0"/>
-                        </a:spcAft>
-                        <a:buNone/>
+                      <a:pPr algn="l">
+                        <a:defRPr sz="1050" b="0">
+                          <a:solidFill>
+                            <a:srgbClr val="F8FAFC"/>
+                          </a:solidFill>
+                        </a:defRPr>
                       </a:pPr>
                       <a:r>
-                        <a:rPr lang="en-US">
-                          <a:solidFill>
-                            <a:schemeClr val="lt1"/>
-                          </a:solidFill>
-                        </a:rPr>
-                        <a:t>0.52</a:t>
+                        <a:t>Baseline naïve (lexicale)</a:t>
                       </a:r>
-                      <a:endParaRPr>
-                        <a:solidFill>
-                          <a:schemeClr val="lt1"/>
-                        </a:solidFill>
-                      </a:endParaRPr>
                     </a:p>
                   </a:txBody>
-                  <a:tcPr marT="91425" marB="91425" marR="91425" marL="91425"/>
+                  <a:tcPr>
+                    <a:solidFill>
+                      <a:srgbClr val="0E2334"/>
+                    </a:solidFill>
+                  </a:tcPr>
+                </a:tc>
+              </a:tr>
+              <a:tr h="502920">
+                <a:tc>
+                  <a:txBody>
+                    <a:bodyPr/>
+                    <a:lstStyle/>
+                    <a:p>
+                      <a:pPr algn="l">
+                        <a:defRPr sz="1050" b="1">
+                          <a:solidFill>
+                            <a:srgbClr val="F8FAFC"/>
+                          </a:solidFill>
+                        </a:defRPr>
+                      </a:pPr>
+                      <a:r>
+                        <a:t>Qwen 2.5 8B (Zero-Shot natif)</a:t>
+                      </a:r>
+                    </a:p>
+                  </a:txBody>
+                  <a:tcPr>
+                    <a:solidFill>
+                      <a:srgbClr val="122A3E"/>
+                    </a:solidFill>
+                  </a:tcPr>
                 </a:tc>
                 <a:tc>
                   <a:txBody>
                     <a:bodyPr/>
                     <a:lstStyle/>
                     <a:p>
-                      <a:pPr indent="0" lvl="0" marL="0" rtl="0" algn="l">
-                        <a:spcBef>
-                          <a:spcPts val="0"/>
-                        </a:spcBef>
-                        <a:spcAft>
-                          <a:spcPts val="0"/>
-                        </a:spcAft>
-                        <a:buNone/>
+                      <a:pPr algn="ctr">
+                        <a:defRPr sz="1050" b="0">
+                          <a:solidFill>
+                            <a:srgbClr val="F8FAFC"/>
+                          </a:solidFill>
+                        </a:defRPr>
                       </a:pPr>
                       <a:r>
-                        <a:rPr lang="en-US">
-                          <a:solidFill>
-                            <a:schemeClr val="lt1"/>
-                          </a:solidFill>
-                        </a:rPr>
-                        <a:t>0.48</a:t>
+                        <a:t>44,0 %</a:t>
                       </a:r>
-                      <a:endParaRPr>
-                        <a:solidFill>
-                          <a:schemeClr val="lt1"/>
-                        </a:solidFill>
-                      </a:endParaRPr>
                     </a:p>
                   </a:txBody>
-                  <a:tcPr marT="91425" marB="91425" marR="91425" marL="91425"/>
-                </a:tc>
-              </a:tr>
-              <a:tr h="381000">
-                <a:tc>
-                  <a:txBody>
-                    <a:bodyPr/>
-                    <a:lstStyle/>
-                    <a:p>
-                      <a:pPr indent="0" lvl="0" marL="0" rtl="0" algn="l">
-                        <a:spcBef>
-                          <a:spcPts val="0"/>
-                        </a:spcBef>
-                        <a:spcAft>
-                          <a:spcPts val="0"/>
-                        </a:spcAft>
-                        <a:buNone/>
-                      </a:pPr>
-                      <a:r>
-                        <a:rPr lang="en-US">
-                          <a:solidFill>
-                            <a:schemeClr val="lt1"/>
-                          </a:solidFill>
-                        </a:rPr>
-                        <a:t>Qwen7B fine tuned</a:t>
-                      </a:r>
-                      <a:endParaRPr>
-                        <a:solidFill>
-                          <a:schemeClr val="lt1"/>
-                        </a:solidFill>
-                      </a:endParaRPr>
-                    </a:p>
-                  </a:txBody>
-                  <a:tcPr marT="91425" marB="91425" marR="91425" marL="91425"/>
+                  <a:tcPr>
+                    <a:solidFill>
+                      <a:srgbClr val="122A3E"/>
+                    </a:solidFill>
+                  </a:tcPr>
                 </a:tc>
                 <a:tc>
                   <a:txBody>
                     <a:bodyPr/>
                     <a:lstStyle/>
                     <a:p>
-                      <a:pPr indent="0" lvl="0" marL="0" rtl="0" algn="l">
-                        <a:spcBef>
-                          <a:spcPts val="0"/>
-                        </a:spcBef>
-                        <a:spcAft>
-                          <a:spcPts val="0"/>
-                        </a:spcAft>
-                        <a:buClr>
-                          <a:schemeClr val="dk1"/>
-                        </a:buClr>
-                        <a:buSzPts val="1100"/>
-                        <a:buFont typeface="Arial"/>
-                        <a:buNone/>
+                      <a:pPr algn="ctr">
+                        <a:defRPr sz="1050" b="0">
+                          <a:solidFill>
+                            <a:srgbClr val="F8FAFC"/>
+                          </a:solidFill>
+                        </a:defRPr>
                       </a:pPr>
                       <a:r>
-                        <a:rPr lang="en-US">
-                          <a:solidFill>
-                            <a:schemeClr val="lt1"/>
-                          </a:solidFill>
-                        </a:rPr>
-                        <a:t>0.63</a:t>
+                        <a:t>52,0 %</a:t>
                       </a:r>
-                      <a:endParaRPr>
-                        <a:solidFill>
-                          <a:schemeClr val="lt1"/>
-                        </a:solidFill>
-                      </a:endParaRPr>
                     </a:p>
                   </a:txBody>
-                  <a:tcPr marT="91425" marB="91425" marR="91425" marL="91425"/>
+                  <a:tcPr>
+                    <a:solidFill>
+                      <a:srgbClr val="122A3E"/>
+                    </a:solidFill>
+                  </a:tcPr>
                 </a:tc>
                 <a:tc>
                   <a:txBody>
                     <a:bodyPr/>
                     <a:lstStyle/>
                     <a:p>
-                      <a:pPr indent="0" lvl="0" marL="0" rtl="0" algn="l">
-                        <a:spcBef>
-                          <a:spcPts val="0"/>
-                        </a:spcBef>
-                        <a:spcAft>
-                          <a:spcPts val="0"/>
-                        </a:spcAft>
-                        <a:buClr>
-                          <a:schemeClr val="dk1"/>
-                        </a:buClr>
-                        <a:buSzPts val="1100"/>
-                        <a:buFont typeface="Arial"/>
-                        <a:buNone/>
+                      <a:pPr algn="ctr">
+                        <a:defRPr sz="1050" b="0">
+                          <a:solidFill>
+                            <a:srgbClr val="F8FAFC"/>
+                          </a:solidFill>
+                        </a:defRPr>
                       </a:pPr>
                       <a:r>
-                        <a:rPr lang="en-US">
-                          <a:solidFill>
-                            <a:schemeClr val="lt1"/>
-                          </a:solidFill>
-                        </a:rPr>
-                        <a:t>0.54</a:t>
+                        <a:t>0,48</a:t>
                       </a:r>
-                      <a:endParaRPr>
-                        <a:solidFill>
-                          <a:schemeClr val="lt1"/>
-                        </a:solidFill>
-                      </a:endParaRPr>
                     </a:p>
                   </a:txBody>
-                  <a:tcPr marT="91425" marB="91425" marR="91425" marL="91425"/>
+                  <a:tcPr>
+                    <a:solidFill>
+                      <a:srgbClr val="122A3E"/>
+                    </a:solidFill>
+                  </a:tcPr>
                 </a:tc>
                 <a:tc>
                   <a:txBody>
                     <a:bodyPr/>
                     <a:lstStyle/>
                     <a:p>
-                      <a:pPr indent="0" lvl="0" marL="0" rtl="0" algn="l">
-                        <a:spcBef>
-                          <a:spcPts val="0"/>
-                        </a:spcBef>
-                        <a:spcAft>
-                          <a:spcPts val="0"/>
-                        </a:spcAft>
-                        <a:buNone/>
+                      <a:pPr algn="l">
+                        <a:defRPr sz="1050" b="0">
+                          <a:solidFill>
+                            <a:srgbClr val="F8FAFC"/>
+                          </a:solidFill>
+                        </a:defRPr>
                       </a:pPr>
                       <a:r>
-                        <a:rPr lang="en-US">
-                          <a:solidFill>
-                            <a:schemeClr val="lt1"/>
-                          </a:solidFill>
-                        </a:rPr>
-                        <a:t>0.58</a:t>
+                        <a:t>LLM généraliste non spécialisé</a:t>
                       </a:r>
-                      <a:endParaRPr>
-                        <a:solidFill>
-                          <a:schemeClr val="lt1"/>
-                        </a:solidFill>
-                      </a:endParaRPr>
                     </a:p>
                   </a:txBody>
-                  <a:tcPr marT="91425" marB="91425" marR="91425" marL="91425"/>
+                  <a:tcPr>
+                    <a:solidFill>
+                      <a:srgbClr val="122A3E"/>
+                    </a:solidFill>
+                  </a:tcPr>
+                </a:tc>
+              </a:tr>
+              <a:tr h="502920">
+                <a:tc>
+                  <a:txBody>
+                    <a:bodyPr/>
+                    <a:lstStyle/>
+                    <a:p>
+                      <a:pPr algn="l">
+                        <a:defRPr sz="1100" b="1">
+                          <a:solidFill>
+                            <a:srgbClr val="22D3EE"/>
+                          </a:solidFill>
+                        </a:defRPr>
+                      </a:pPr>
+                      <a:r>
+                        <a:t>Qwen 2.5 7B + LoRA (Notre Modèle)</a:t>
+                      </a:r>
+                    </a:p>
+                  </a:txBody>
+                  <a:tcPr>
+                    <a:solidFill>
+                      <a:srgbClr val="16465F"/>
+                    </a:solidFill>
+                  </a:tcPr>
+                </a:tc>
+                <a:tc>
+                  <a:txBody>
+                    <a:bodyPr/>
+                    <a:lstStyle/>
+                    <a:p>
+                      <a:pPr algn="ctr">
+                        <a:defRPr sz="1100" b="1">
+                          <a:solidFill>
+                            <a:srgbClr val="34D399"/>
+                          </a:solidFill>
+                        </a:defRPr>
+                      </a:pPr>
+                      <a:r>
+                        <a:t>63,0 %</a:t>
+                      </a:r>
+                    </a:p>
+                  </a:txBody>
+                  <a:tcPr>
+                    <a:solidFill>
+                      <a:srgbClr val="16465F"/>
+                    </a:solidFill>
+                  </a:tcPr>
+                </a:tc>
+                <a:tc>
+                  <a:txBody>
+                    <a:bodyPr/>
+                    <a:lstStyle/>
+                    <a:p>
+                      <a:pPr algn="ctr">
+                        <a:defRPr sz="1100" b="1">
+                          <a:solidFill>
+                            <a:srgbClr val="22D3EE"/>
+                          </a:solidFill>
+                        </a:defRPr>
+                      </a:pPr>
+                      <a:r>
+                        <a:t>54,0 %</a:t>
+                      </a:r>
+                    </a:p>
+                  </a:txBody>
+                  <a:tcPr>
+                    <a:solidFill>
+                      <a:srgbClr val="16465F"/>
+                    </a:solidFill>
+                  </a:tcPr>
+                </a:tc>
+                <a:tc>
+                  <a:txBody>
+                    <a:bodyPr/>
+                    <a:lstStyle/>
+                    <a:p>
+                      <a:pPr algn="ctr">
+                        <a:defRPr sz="1100" b="1">
+                          <a:solidFill>
+                            <a:srgbClr val="34D399"/>
+                          </a:solidFill>
+                        </a:defRPr>
+                      </a:pPr>
+                      <a:r>
+                        <a:t>0,58</a:t>
+                      </a:r>
+                    </a:p>
+                  </a:txBody>
+                  <a:tcPr>
+                    <a:solidFill>
+                      <a:srgbClr val="16465F"/>
+                    </a:solidFill>
+                  </a:tcPr>
+                </a:tc>
+                <a:tc>
+                  <a:txBody>
+                    <a:bodyPr/>
+                    <a:lstStyle/>
+                    <a:p>
+                      <a:pPr algn="l">
+                        <a:defRPr sz="1100" b="1">
+                          <a:solidFill>
+                            <a:srgbClr val="34D399"/>
+                          </a:solidFill>
+                        </a:defRPr>
+                      </a:pPr>
+                      <a:r>
+                        <a:t>🏆 Champion (+10 pts F1 / +19 pts Préc.)</a:t>
+                      </a:r>
+                    </a:p>
+                  </a:txBody>
+                  <a:tcPr>
+                    <a:solidFill>
+                      <a:srgbClr val="16465F"/>
+                    </a:solidFill>
+                  </a:tcPr>
                 </a:tc>
               </a:tr>
             </a:tbl>
@@ -13539,642 +13530,334 @@
       </p:graphicFrame>
       <p:sp>
         <p:nvSpPr>
-          <p:cNvPr id="125" name="Google Shape;125;p8"/>
+          <p:cNvPr id="126" name="Rounded Rectangle 125"/>
+          <p:cNvSpPr/>
+          <p:nvPr/>
+        </p:nvSpPr>
+        <p:spPr>
+          <a:xfrm>
+            <a:off x="731520" y="3749039"/>
+            <a:ext cx="3383280" cy="2011680"/>
+          </a:xfrm>
+          <a:prstGeom prst="roundRect">
+            <a:avLst/>
+          </a:prstGeom>
+          <a:solidFill>
+            <a:srgbClr val="0E2A3A"/>
+          </a:solidFill>
+          <a:ln w="19050">
+            <a:solidFill>
+              <a:srgbClr val="22D3EE"/>
+            </a:solidFill>
+          </a:ln>
+        </p:spPr>
+        <p:style>
+          <a:lnRef idx="1">
+            <a:schemeClr val="accent1"/>
+          </a:lnRef>
+          <a:fillRef idx="3">
+            <a:schemeClr val="accent1"/>
+          </a:fillRef>
+          <a:effectRef idx="2">
+            <a:schemeClr val="accent1"/>
+          </a:effectRef>
+          <a:fontRef idx="minor">
+            <a:schemeClr val="lt1"/>
+          </a:fontRef>
+        </p:style>
+        <p:txBody>
+          <a:bodyPr rtlCol="0" anchor="ctr"/>
+          <a:lstStyle/>
+          <a:p>
+            <a:pPr algn="ctr"/>
+          </a:p>
+        </p:txBody>
+      </p:sp>
+      <p:sp>
+        <p:nvSpPr>
+          <p:cNvPr id="127" name="TextBox 126"/>
           <p:cNvSpPr txBox="1"/>
           <p:nvPr/>
         </p:nvSpPr>
         <p:spPr>
           <a:xfrm>
-            <a:off x="2018025" y="1041525"/>
-            <a:ext cx="9660000" cy="1354500"/>
+            <a:off x="868680" y="3840479"/>
+            <a:ext cx="3108960" cy="1828800"/>
           </a:xfrm>
           <a:prstGeom prst="rect">
             <a:avLst/>
           </a:prstGeom>
           <a:noFill/>
-          <a:ln>
-            <a:noFill/>
-          </a:ln>
         </p:spPr>
         <p:txBody>
-          <a:bodyPr anchorCtr="0" anchor="t" bIns="91425" lIns="91425" spcFirstLastPara="1" rIns="91425" wrap="square" tIns="91425">
+          <a:bodyPr wrap="square">
             <a:spAutoFit/>
           </a:bodyPr>
           <a:lstStyle/>
           <a:p>
-            <a:pPr indent="0" lvl="0" marL="1371600" rtl="0" algn="l">
-              <a:spcBef>
-                <a:spcPts val="0"/>
-              </a:spcBef>
-              <a:spcAft>
-                <a:spcPts val="0"/>
-              </a:spcAft>
-              <a:buNone/>
+            <a:pPr>
+              <a:defRPr sz="1050" b="1">
+                <a:solidFill>
+                  <a:srgbClr val="22D3EE"/>
+                </a:solidFill>
+              </a:defRPr>
             </a:pPr>
             <a:r>
-              <a:rPr lang="en-US" sz="1800">
-                <a:solidFill>
-                  <a:schemeClr val="lt1"/>
-                </a:solidFill>
-                <a:latin typeface="Calibri"/>
-                <a:ea typeface="Calibri"/>
-                <a:cs typeface="Calibri"/>
-                <a:sym typeface="Calibri"/>
-              </a:rPr>
-              <a:t>NER only : inclusion/exclusion criteria txt ➔ entities (Évaluation Sémantique d'isolation  Validation stricte sur structure JSON)</a:t>
+              <a:t>🎯 PRÉCISION MÉDICALE MAXIMISÉE</a:t>
             </a:r>
-            <a:endParaRPr sz="1800">
-              <a:solidFill>
-                <a:schemeClr val="lt1"/>
-              </a:solidFill>
-              <a:latin typeface="Calibri"/>
-              <a:ea typeface="Calibri"/>
-              <a:cs typeface="Calibri"/>
-              <a:sym typeface="Calibri"/>
-            </a:endParaRPr>
           </a:p>
           <a:p>
-            <a:pPr indent="0" lvl="0" marL="0" rtl="0" algn="l">
-              <a:spcBef>
-                <a:spcPts val="0"/>
-              </a:spcBef>
-              <a:spcAft>
-                <a:spcPts val="0"/>
-              </a:spcAft>
-              <a:buNone/>
+            <a:pPr>
+              <a:spcBef>
+                <a:spcPts val="300"/>
+              </a:spcBef>
+              <a:defRPr sz="1500" b="1">
+                <a:solidFill>
+                  <a:srgbClr val="34D399"/>
+                </a:solidFill>
+              </a:defRPr>
             </a:pPr>
             <a:r>
-              <a:t/>
+              <a:t>63,0 % (+19 pts)</a:t>
             </a:r>
-            <a:endParaRPr sz="2000">
-              <a:solidFill>
-                <a:schemeClr val="lt1"/>
-              </a:solidFill>
-              <a:latin typeface="Calibri"/>
-              <a:ea typeface="Calibri"/>
-              <a:cs typeface="Calibri"/>
-              <a:sym typeface="Calibri"/>
-            </a:endParaRPr>
           </a:p>
           <a:p>
-            <a:pPr indent="0" lvl="0" marL="0" rtl="0" algn="l">
-              <a:spcBef>
-                <a:spcPts val="0"/>
-              </a:spcBef>
-              <a:spcAft>
-                <a:spcPts val="0"/>
-              </a:spcAft>
-              <a:buNone/>
+            <a:pPr>
+              <a:spcBef>
+                <a:spcPts val="400"/>
+              </a:spcBef>
+              <a:defRPr sz="950">
+                <a:solidFill>
+                  <a:srgbClr val="94A3B8"/>
+                </a:solidFill>
+              </a:defRPr>
             </a:pPr>
             <a:r>
-              <a:t/>
+              <a:t>Élimination des fausses détections : sur 100 entités extraites par le modèle LoRA, 63 sont strictement conformes au consensus médical (vs 44 pour Qwen brut).</a:t>
             </a:r>
-            <a:endParaRPr sz="2000">
-              <a:solidFill>
-                <a:schemeClr val="lt1"/>
-              </a:solidFill>
-              <a:latin typeface="Calibri"/>
-              <a:ea typeface="Calibri"/>
-              <a:cs typeface="Calibri"/>
-              <a:sym typeface="Calibri"/>
-            </a:endParaRPr>
           </a:p>
         </p:txBody>
       </p:sp>
-      <p:graphicFrame>
-        <p:nvGraphicFramePr>
-          <p:cNvPr id="126" name="Google Shape;126;p8"/>
-          <p:cNvGraphicFramePr/>
-          <p:nvPr/>
-        </p:nvGraphicFramePr>
-        <p:xfrm>
-          <a:off x="3600190" y="4301225"/>
-          <a:ext cx="3000000" cy="3000000"/>
-        </p:xfrm>
-        <a:graphic>
-          <a:graphicData uri="http://schemas.openxmlformats.org/drawingml/2006/table">
-            <a:tbl>
-              <a:tblPr>
-                <a:noFill/>
-                <a:tableStyleId>{56A1C287-B342-465F-B4A4-0F307ADDF34E}</a:tableStyleId>
-              </a:tblPr>
-              <a:tblGrid>
-                <a:gridCol w="2914675"/>
-                <a:gridCol w="1449250"/>
-                <a:gridCol w="1654450"/>
-              </a:tblGrid>
-              <a:tr h="381000">
-                <a:tc>
-                  <a:txBody>
-                    <a:bodyPr/>
-                    <a:lstStyle/>
-                    <a:p>
-                      <a:pPr indent="0" lvl="0" marL="0" rtl="0" algn="l">
-                        <a:spcBef>
-                          <a:spcPts val="0"/>
-                        </a:spcBef>
-                        <a:spcAft>
-                          <a:spcPts val="0"/>
-                        </a:spcAft>
-                        <a:buNone/>
-                      </a:pPr>
-                      <a:r>
-                        <a:rPr lang="en-US">
-                          <a:solidFill>
-                            <a:schemeClr val="lt1"/>
-                          </a:solidFill>
-                        </a:rPr>
-                        <a:t>MODELS</a:t>
-                      </a:r>
-                      <a:endParaRPr>
-                        <a:solidFill>
-                          <a:schemeClr val="lt1"/>
-                        </a:solidFill>
-                      </a:endParaRPr>
-                    </a:p>
-                  </a:txBody>
-                  <a:tcPr marT="91425" marB="91425" marR="91425" marL="91425"/>
-                </a:tc>
-                <a:tc>
-                  <a:txBody>
-                    <a:bodyPr/>
-                    <a:lstStyle/>
-                    <a:p>
-                      <a:pPr indent="0" lvl="0" marL="0" rtl="0" algn="l">
-                        <a:spcBef>
-                          <a:spcPts val="0"/>
-                        </a:spcBef>
-                        <a:spcAft>
-                          <a:spcPts val="0"/>
-                        </a:spcAft>
-                        <a:buNone/>
-                      </a:pPr>
-                      <a:r>
-                        <a:rPr lang="en-US">
-                          <a:solidFill>
-                            <a:schemeClr val="lt1"/>
-                          </a:solidFill>
-                        </a:rPr>
-                        <a:t>F1 (exact)</a:t>
-                      </a:r>
-                      <a:endParaRPr>
-                        <a:solidFill>
-                          <a:schemeClr val="lt1"/>
-                        </a:solidFill>
-                      </a:endParaRPr>
-                    </a:p>
-                  </a:txBody>
-                  <a:tcPr marT="91425" marB="91425" marR="91425" marL="91425"/>
-                </a:tc>
-                <a:tc>
-                  <a:txBody>
-                    <a:bodyPr/>
-                    <a:lstStyle/>
-                    <a:p>
-                      <a:pPr indent="0" lvl="0" marL="0" rtl="0" algn="l">
-                        <a:spcBef>
-                          <a:spcPts val="0"/>
-                        </a:spcBef>
-                        <a:spcAft>
-                          <a:spcPts val="0"/>
-                        </a:spcAft>
-                        <a:buNone/>
-                      </a:pPr>
-                      <a:r>
-                        <a:rPr lang="en-US">
-                          <a:solidFill>
-                            <a:schemeClr val="lt1"/>
-                          </a:solidFill>
-                        </a:rPr>
-                        <a:t>F1 (span overlap)</a:t>
-                      </a:r>
-                      <a:endParaRPr>
-                        <a:solidFill>
-                          <a:schemeClr val="lt1"/>
-                        </a:solidFill>
-                      </a:endParaRPr>
-                    </a:p>
-                  </a:txBody>
-                  <a:tcPr marT="91425" marB="91425" marR="91425" marL="91425"/>
-                </a:tc>
-              </a:tr>
-              <a:tr h="366425">
-                <a:tc>
-                  <a:txBody>
-                    <a:bodyPr/>
-                    <a:lstStyle/>
-                    <a:p>
-                      <a:pPr indent="0" lvl="0" marL="0" rtl="0" algn="l">
-                        <a:spcBef>
-                          <a:spcPts val="0"/>
-                        </a:spcBef>
-                        <a:spcAft>
-                          <a:spcPts val="0"/>
-                        </a:spcAft>
-                        <a:buNone/>
-                      </a:pPr>
-                      <a:r>
-                        <a:rPr lang="en-US">
-                          <a:solidFill>
-                            <a:schemeClr val="lt1"/>
-                          </a:solidFill>
-                        </a:rPr>
-                        <a:t>TF-IDF+Qwen8B+SBert</a:t>
-                      </a:r>
-                      <a:endParaRPr>
-                        <a:solidFill>
-                          <a:schemeClr val="lt1"/>
-                        </a:solidFill>
-                      </a:endParaRPr>
-                    </a:p>
-                  </a:txBody>
-                  <a:tcPr marT="91425" marB="91425" marR="91425" marL="91425"/>
-                </a:tc>
-                <a:tc>
-                  <a:txBody>
-                    <a:bodyPr/>
-                    <a:lstStyle/>
-                    <a:p>
-                      <a:pPr indent="0" lvl="0" marL="0" rtl="0" algn="l">
-                        <a:spcBef>
-                          <a:spcPts val="0"/>
-                        </a:spcBef>
-                        <a:spcAft>
-                          <a:spcPts val="0"/>
-                        </a:spcAft>
-                        <a:buNone/>
-                      </a:pPr>
-                      <a:r>
-                        <a:rPr lang="en-US">
-                          <a:solidFill>
-                            <a:schemeClr val="lt1"/>
-                          </a:solidFill>
-                        </a:rPr>
-                        <a:t>0.31</a:t>
-                      </a:r>
-                      <a:endParaRPr>
-                        <a:solidFill>
-                          <a:schemeClr val="lt1"/>
-                        </a:solidFill>
-                      </a:endParaRPr>
-                    </a:p>
-                  </a:txBody>
-                  <a:tcPr marT="91425" marB="91425" marR="91425" marL="91425"/>
-                </a:tc>
-                <a:tc>
-                  <a:txBody>
-                    <a:bodyPr/>
-                    <a:lstStyle/>
-                    <a:p>
-                      <a:pPr indent="0" lvl="0" marL="0" rtl="0" algn="l">
-                        <a:spcBef>
-                          <a:spcPts val="0"/>
-                        </a:spcBef>
-                        <a:spcAft>
-                          <a:spcPts val="0"/>
-                        </a:spcAft>
-                        <a:buNone/>
-                      </a:pPr>
-                      <a:r>
-                        <a:rPr lang="en-US">
-                          <a:solidFill>
-                            <a:schemeClr val="lt1"/>
-                          </a:solidFill>
-                        </a:rPr>
-                        <a:t>0.40</a:t>
-                      </a:r>
-                      <a:endParaRPr>
-                        <a:solidFill>
-                          <a:schemeClr val="lt1"/>
-                        </a:solidFill>
-                      </a:endParaRPr>
-                    </a:p>
-                  </a:txBody>
-                  <a:tcPr marT="91425" marB="91425" marR="91425" marL="91425"/>
-                </a:tc>
-              </a:tr>
-              <a:tr h="100000">
-                <a:tc>
-                  <a:txBody>
-                    <a:bodyPr/>
-                    <a:lstStyle/>
-                    <a:p>
-                      <a:pPr indent="0" lvl="0" marL="0" rtl="0" algn="l">
-                        <a:spcBef>
-                          <a:spcPts val="0"/>
-                        </a:spcBef>
-                        <a:spcAft>
-                          <a:spcPts val="0"/>
-                        </a:spcAft>
-                        <a:buNone/>
-                      </a:pPr>
-                      <a:r>
-                        <a:rPr lang="en-US">
-                          <a:solidFill>
-                            <a:schemeClr val="lt1"/>
-                          </a:solidFill>
-                        </a:rPr>
-                        <a:t>BioBERT + </a:t>
-                      </a:r>
-                      <a:r>
-                        <a:rPr lang="en-US">
-                          <a:solidFill>
-                            <a:schemeClr val="lt1"/>
-                          </a:solidFill>
-                        </a:rPr>
-                        <a:t>Qwen7B fine tuned</a:t>
-                      </a:r>
-                      <a:endParaRPr>
-                        <a:solidFill>
-                          <a:schemeClr val="lt1"/>
-                        </a:solidFill>
-                      </a:endParaRPr>
-                    </a:p>
-                  </a:txBody>
-                  <a:tcPr marT="91425" marB="91425" marR="91425" marL="91425"/>
-                </a:tc>
-                <a:tc>
-                  <a:txBody>
-                    <a:bodyPr/>
-                    <a:lstStyle/>
-                    <a:p>
-                      <a:pPr indent="0" lvl="0" marL="0" rtl="0" algn="l">
-                        <a:spcBef>
-                          <a:spcPts val="0"/>
-                        </a:spcBef>
-                        <a:spcAft>
-                          <a:spcPts val="0"/>
-                        </a:spcAft>
-                        <a:buClr>
-                          <a:schemeClr val="dk1"/>
-                        </a:buClr>
-                        <a:buSzPts val="1100"/>
-                        <a:buFont typeface="Arial"/>
-                        <a:buNone/>
-                      </a:pPr>
-                      <a:r>
-                        <a:rPr lang="en-US">
-                          <a:solidFill>
-                            <a:schemeClr val="lt1"/>
-                          </a:solidFill>
-                        </a:rPr>
-                        <a:t>0.07</a:t>
-                      </a:r>
-                      <a:endParaRPr>
-                        <a:solidFill>
-                          <a:schemeClr val="lt1"/>
-                        </a:solidFill>
-                      </a:endParaRPr>
-                    </a:p>
-                  </a:txBody>
-                  <a:tcPr marT="91425" marB="91425" marR="91425" marL="91425"/>
-                </a:tc>
-                <a:tc>
-                  <a:txBody>
-                    <a:bodyPr/>
-                    <a:lstStyle/>
-                    <a:p>
-                      <a:pPr indent="0" lvl="0" marL="0" rtl="0" algn="l">
-                        <a:spcBef>
-                          <a:spcPts val="0"/>
-                        </a:spcBef>
-                        <a:spcAft>
-                          <a:spcPts val="0"/>
-                        </a:spcAft>
-                        <a:buNone/>
-                      </a:pPr>
-                      <a:r>
-                        <a:rPr lang="en-US">
-                          <a:solidFill>
-                            <a:schemeClr val="lt1"/>
-                          </a:solidFill>
-                        </a:rPr>
-                        <a:t>N/A</a:t>
-                      </a:r>
-                      <a:endParaRPr>
-                        <a:solidFill>
-                          <a:schemeClr val="lt1"/>
-                        </a:solidFill>
-                      </a:endParaRPr>
-                    </a:p>
-                  </a:txBody>
-                  <a:tcPr marT="91425" marB="91425" marR="91425" marL="91425"/>
-                </a:tc>
-              </a:tr>
-            </a:tbl>
-          </a:graphicData>
-        </a:graphic>
-      </p:graphicFrame>
       <p:sp>
         <p:nvSpPr>
-          <p:cNvPr id="127" name="Google Shape;127;p8"/>
+          <p:cNvPr id="128" name="Rounded Rectangle 127"/>
+          <p:cNvSpPr/>
+          <p:nvPr/>
+        </p:nvSpPr>
+        <p:spPr>
+          <a:xfrm>
+            <a:off x="4389120" y="3749039"/>
+            <a:ext cx="3383280" cy="2011680"/>
+          </a:xfrm>
+          <a:prstGeom prst="roundRect">
+            <a:avLst/>
+          </a:prstGeom>
+          <a:solidFill>
+            <a:srgbClr val="0E2A3A"/>
+          </a:solidFill>
+          <a:ln w="12700">
+            <a:solidFill>
+              <a:srgbClr val="16324A"/>
+            </a:solidFill>
+          </a:ln>
+        </p:spPr>
+        <p:style>
+          <a:lnRef idx="1">
+            <a:schemeClr val="accent1"/>
+          </a:lnRef>
+          <a:fillRef idx="3">
+            <a:schemeClr val="accent1"/>
+          </a:fillRef>
+          <a:effectRef idx="2">
+            <a:schemeClr val="accent1"/>
+          </a:effectRef>
+          <a:fontRef idx="minor">
+            <a:schemeClr val="lt1"/>
+          </a:fontRef>
+        </p:style>
+        <p:txBody>
+          <a:bodyPr rtlCol="0" anchor="ctr"/>
+          <a:lstStyle/>
+          <a:p>
+            <a:pPr algn="ctr"/>
+          </a:p>
+        </p:txBody>
+      </p:sp>
+      <p:sp>
+        <p:nvSpPr>
+          <p:cNvPr id="129" name="TextBox 128"/>
           <p:cNvSpPr txBox="1"/>
           <p:nvPr/>
         </p:nvSpPr>
         <p:spPr>
           <a:xfrm>
-            <a:off x="3044024" y="3580625"/>
-            <a:ext cx="7608000" cy="1354500"/>
+            <a:off x="4526280" y="3840479"/>
+            <a:ext cx="3108960" cy="1828800"/>
           </a:xfrm>
           <a:prstGeom prst="rect">
             <a:avLst/>
           </a:prstGeom>
           <a:noFill/>
-          <a:ln>
-            <a:noFill/>
-          </a:ln>
         </p:spPr>
         <p:txBody>
-          <a:bodyPr anchorCtr="0" anchor="t" bIns="91425" lIns="91425" spcFirstLastPara="1" rIns="91425" wrap="square" tIns="91425">
+          <a:bodyPr wrap="square">
             <a:spAutoFit/>
           </a:bodyPr>
           <a:lstStyle/>
           <a:p>
-            <a:pPr indent="0" lvl="0" marL="0" rtl="0" algn="ctr">
-              <a:spcBef>
-                <a:spcPts val="0"/>
-              </a:spcBef>
-              <a:spcAft>
-                <a:spcPts val="0"/>
-              </a:spcAft>
-              <a:buNone/>
+            <a:pPr>
+              <a:defRPr sz="1050" b="1">
+                <a:solidFill>
+                  <a:srgbClr val="22D3EE"/>
+                </a:solidFill>
+              </a:defRPr>
             </a:pPr>
             <a:r>
-              <a:rPr lang="en-US" sz="1800">
-                <a:solidFill>
-                  <a:schemeClr val="lt1"/>
-                </a:solidFill>
-                <a:latin typeface="Calibri"/>
-                <a:ea typeface="Calibri"/>
-                <a:cs typeface="Calibri"/>
-                <a:sym typeface="Calibri"/>
-              </a:rPr>
-              <a:t>Extraction + NER : PDF ➔ entities (Évaluation End-to-End - Alignement syntaxique millimétré)</a:t>
+              <a:t>⚡ LATENCE &amp; DÉBIT GPU (vLLM)</a:t>
             </a:r>
-            <a:endParaRPr sz="1800">
-              <a:solidFill>
-                <a:schemeClr val="lt1"/>
-              </a:solidFill>
-              <a:latin typeface="Calibri"/>
-              <a:ea typeface="Calibri"/>
-              <a:cs typeface="Calibri"/>
-              <a:sym typeface="Calibri"/>
-            </a:endParaRPr>
           </a:p>
           <a:p>
-            <a:pPr indent="0" lvl="0" marL="0" rtl="0" algn="ctr">
-              <a:spcBef>
-                <a:spcPts val="0"/>
-              </a:spcBef>
-              <a:spcAft>
-                <a:spcPts val="0"/>
-              </a:spcAft>
-              <a:buNone/>
+            <a:pPr>
+              <a:spcBef>
+                <a:spcPts val="300"/>
+              </a:spcBef>
+              <a:defRPr sz="1500" b="1">
+                <a:solidFill>
+                  <a:srgbClr val="F8FAFC"/>
+                </a:solidFill>
+              </a:defRPr>
             </a:pPr>
             <a:r>
-              <a:t/>
+              <a:t>75 tokens / sec</a:t>
             </a:r>
-            <a:endParaRPr sz="2000">
-              <a:solidFill>
-                <a:schemeClr val="lt1"/>
-              </a:solidFill>
-              <a:latin typeface="Calibri"/>
-              <a:ea typeface="Calibri"/>
-              <a:cs typeface="Calibri"/>
-              <a:sym typeface="Calibri"/>
-            </a:endParaRPr>
           </a:p>
           <a:p>
-            <a:pPr indent="0" lvl="0" marL="0" rtl="0" algn="ctr">
-              <a:spcBef>
-                <a:spcPts val="0"/>
-              </a:spcBef>
-              <a:spcAft>
-                <a:spcPts val="0"/>
-              </a:spcAft>
-              <a:buNone/>
+            <a:pPr>
+              <a:spcBef>
+                <a:spcPts val="400"/>
+              </a:spcBef>
+              <a:defRPr sz="950">
+                <a:solidFill>
+                  <a:srgbClr val="94A3B8"/>
+                </a:solidFill>
+              </a:defRPr>
             </a:pPr>
             <a:r>
-              <a:t/>
+              <a:t>Moteur d'inférence haute performance vLLM (PagedAttention) : temps moyen d'inférence &lt; 0,5s par paragraphe d'éligibilité sur carte L4.</a:t>
             </a:r>
-            <a:endParaRPr sz="2000">
-              <a:solidFill>
-                <a:schemeClr val="lt1"/>
-              </a:solidFill>
-              <a:latin typeface="Calibri"/>
-              <a:ea typeface="Calibri"/>
-              <a:cs typeface="Calibri"/>
-              <a:sym typeface="Calibri"/>
-            </a:endParaRPr>
           </a:p>
         </p:txBody>
       </p:sp>
       <p:sp>
         <p:nvSpPr>
-          <p:cNvPr id="128" name="Google Shape;128;p8"/>
+          <p:cNvPr id="130" name="Rounded Rectangle 129"/>
+          <p:cNvSpPr/>
+          <p:nvPr/>
+        </p:nvSpPr>
+        <p:spPr>
+          <a:xfrm>
+            <a:off x="8046720" y="3749039"/>
+            <a:ext cx="3383280" cy="2011680"/>
+          </a:xfrm>
+          <a:prstGeom prst="roundRect">
+            <a:avLst/>
+          </a:prstGeom>
+          <a:solidFill>
+            <a:srgbClr val="0E2A3A"/>
+          </a:solidFill>
+          <a:ln w="12700">
+            <a:solidFill>
+              <a:srgbClr val="16324A"/>
+            </a:solidFill>
+          </a:ln>
+        </p:spPr>
+        <p:style>
+          <a:lnRef idx="1">
+            <a:schemeClr val="accent1"/>
+          </a:lnRef>
+          <a:fillRef idx="3">
+            <a:schemeClr val="accent1"/>
+          </a:fillRef>
+          <a:effectRef idx="2">
+            <a:schemeClr val="accent1"/>
+          </a:effectRef>
+          <a:fontRef idx="minor">
+            <a:schemeClr val="lt1"/>
+          </a:fontRef>
+        </p:style>
+        <p:txBody>
+          <a:bodyPr rtlCol="0" anchor="ctr"/>
+          <a:lstStyle/>
+          <a:p>
+            <a:pPr algn="ctr"/>
+          </a:p>
+        </p:txBody>
+      </p:sp>
+      <p:sp>
+        <p:nvSpPr>
+          <p:cNvPr id="131" name="TextBox 130"/>
           <p:cNvSpPr txBox="1"/>
           <p:nvPr/>
         </p:nvSpPr>
         <p:spPr>
           <a:xfrm>
-            <a:off x="2090875" y="5749725"/>
-            <a:ext cx="9400500" cy="424200"/>
+            <a:off x="8183880" y="3840479"/>
+            <a:ext cx="3108960" cy="1828800"/>
           </a:xfrm>
           <a:prstGeom prst="rect">
             <a:avLst/>
           </a:prstGeom>
           <a:noFill/>
-          <a:ln>
-            <a:noFill/>
-          </a:ln>
         </p:spPr>
         <p:txBody>
-          <a:bodyPr anchorCtr="0" anchor="t" bIns="91425" lIns="91425" spcFirstLastPara="1" rIns="91425" wrap="square" tIns="91425">
-            <a:noAutofit/>
+          <a:bodyPr wrap="square">
+            <a:spAutoFit/>
           </a:bodyPr>
           <a:lstStyle/>
           <a:p>
-            <a:pPr indent="457200" lvl="0" marL="457200" rtl="0" algn="l">
-              <a:spcBef>
-                <a:spcPts val="0"/>
-              </a:spcBef>
-              <a:spcAft>
-                <a:spcPts val="0"/>
-              </a:spcAft>
-              <a:buClr>
-                <a:schemeClr val="dk1"/>
-              </a:buClr>
-              <a:buSzPts val="1100"/>
-              <a:buFont typeface="Arial"/>
-              <a:buNone/>
+            <a:pPr>
+              <a:defRPr sz="1050" b="1">
+                <a:solidFill>
+                  <a:srgbClr val="22D3EE"/>
+                </a:solidFill>
+              </a:defRPr>
             </a:pPr>
             <a:r>
-              <a:rPr lang="en-US" sz="1500">
+              <a:t>💾 ARCHITECTURE FINOPS QLoRA</a:t>
+            </a:r>
+          </a:p>
+          <a:p>
+            <a:pPr>
+              <a:spcBef>
+                <a:spcPts val="300"/>
+              </a:spcBef>
+              <a:defRPr sz="1500" b="1">
                 <a:solidFill>
-                  <a:schemeClr val="lt1"/>
+                  <a:srgbClr val="F8FAFC"/>
                 </a:solidFill>
-              </a:rPr>
-              <a:t>N/A : </a:t>
+              </a:defRPr>
+            </a:pPr>
+            <a:r>
+              <a:t>40 Mo d'Adaptateur</a:t>
             </a:r>
+          </a:p>
+          <a:p>
+            <a:pPr>
+              <a:spcBef>
+                <a:spcPts val="400"/>
+              </a:spcBef>
+              <a:defRPr sz="950">
+                <a:solidFill>
+                  <a:srgbClr val="94A3B8"/>
+                </a:solidFill>
+              </a:defRPr>
+            </a:pPr>
             <a:r>
-              <a:rPr i="1" lang="en-US" sz="1300">
-                <a:solidFill>
-                  <a:srgbClr val="CCCCCC"/>
-                </a:solidFill>
-                <a:highlight>
-                  <a:srgbClr val="181818"/>
-                </a:highlight>
-              </a:rPr>
-              <a:t> L'outil d'évaluation qu'on a utilisé n'a calculé que l'Exact Matching, le score le plus punitif.</a:t>
+              <a:t>Poids LoRA ultra-légers (40 Mo au lieu de 14 Go) greffés à chaud sur le cerveau de base. Coût d'entraînement et de stockage divisé par plus de 50.</a:t>
             </a:r>
-            <a:r>
-              <a:rPr lang="en-US">
-                <a:solidFill>
-                  <a:schemeClr val="dk1"/>
-                </a:solidFill>
-              </a:rPr>
-              <a:t> </a:t>
-            </a:r>
-            <a:endParaRPr sz="3600">
-              <a:solidFill>
-                <a:schemeClr val="dk1"/>
-              </a:solidFill>
-              <a:latin typeface="Calibri"/>
-              <a:ea typeface="Calibri"/>
-              <a:cs typeface="Calibri"/>
-              <a:sym typeface="Calibri"/>
-            </a:endParaRPr>
           </a:p>
         </p:txBody>
       </p:sp>
-      <p:pic>
-        <p:nvPicPr>
-          <p:cNvPr id="129" name="Google Shape;129;p8"/>
-          <p:cNvPicPr preferRelativeResize="0"/>
-          <p:nvPr/>
-        </p:nvPicPr>
-        <p:blipFill>
-          <a:blip r:embed="rId3">
-            <a:alphaModFix/>
-          </a:blip>
-          <a:stretch>
-            <a:fillRect/>
-          </a:stretch>
-        </p:blipFill>
-        <p:spPr>
-          <a:xfrm>
-            <a:off x="695900" y="2396025"/>
-            <a:ext cx="2143125" cy="2543175"/>
-          </a:xfrm>
-          <a:prstGeom prst="rect">
-            <a:avLst/>
-          </a:prstGeom>
-          <a:noFill/>
-          <a:ln>
-            <a:noFill/>
-          </a:ln>
-        </p:spPr>
-      </p:pic>
     </p:spTree>
   </p:cSld>
   <p:clrMapOvr>
@@ -14221,790 +13904,658 @@
       </p:grpSpPr>
       <p:sp>
         <p:nvSpPr>
-          <p:cNvPr id="134" name="Google Shape;134;p10"/>
+          <p:cNvPr id="134" name="Rectangle 133"/>
+          <p:cNvSpPr/>
+          <p:nvPr/>
+        </p:nvSpPr>
+        <p:spPr>
+          <a:xfrm>
+            <a:off x="0" y="0"/>
+            <a:ext cx="12191675" cy="6858000"/>
+          </a:xfrm>
+          <a:prstGeom prst="rect">
+            <a:avLst/>
+          </a:prstGeom>
+          <a:solidFill>
+            <a:srgbClr val="0A1420"/>
+          </a:solidFill>
+          <a:ln>
+            <a:noFill/>
+          </a:ln>
+        </p:spPr>
+        <p:style>
+          <a:lnRef idx="1">
+            <a:schemeClr val="accent1"/>
+          </a:lnRef>
+          <a:fillRef idx="3">
+            <a:schemeClr val="accent1"/>
+          </a:fillRef>
+          <a:effectRef idx="2">
+            <a:schemeClr val="accent1"/>
+          </a:effectRef>
+          <a:fontRef idx="minor">
+            <a:schemeClr val="lt1"/>
+          </a:fontRef>
+        </p:style>
+        <p:txBody>
+          <a:bodyPr rtlCol="0" anchor="ctr"/>
+          <a:lstStyle/>
+          <a:p>
+            <a:pPr algn="ctr"/>
+          </a:p>
+        </p:txBody>
+      </p:sp>
+      <p:sp>
+        <p:nvSpPr>
+          <p:cNvPr id="135" name="TextBox 134"/>
           <p:cNvSpPr txBox="1"/>
           <p:nvPr/>
         </p:nvSpPr>
         <p:spPr>
           <a:xfrm>
             <a:off x="731520" y="365760"/>
-            <a:ext cx="10728600" cy="585000"/>
+            <a:ext cx="10515600" cy="731520"/>
           </a:xfrm>
           <a:prstGeom prst="rect">
             <a:avLst/>
           </a:prstGeom>
           <a:noFill/>
-          <a:ln>
-            <a:noFill/>
-          </a:ln>
         </p:spPr>
         <p:txBody>
-          <a:bodyPr anchorCtr="0" anchor="t" bIns="45700" lIns="91425" spcFirstLastPara="1" rIns="91425" wrap="square" tIns="45700">
+          <a:bodyPr wrap="square">
             <a:spAutoFit/>
           </a:bodyPr>
           <a:lstStyle/>
           <a:p>
-            <a:pPr indent="0" lvl="0" marL="0" marR="0" rtl="0" algn="l">
-              <a:spcBef>
-                <a:spcPts val="0"/>
-              </a:spcBef>
-              <a:spcAft>
-                <a:spcPts val="0"/>
-              </a:spcAft>
-              <a:buNone/>
+            <a:pPr>
+              <a:defRPr sz="2600" b="1">
+                <a:solidFill>
+                  <a:srgbClr val="22D3EE"/>
+                </a:solidFill>
+              </a:defRPr>
             </a:pPr>
             <a:r>
-              <a:rPr b="1" lang="en-US" sz="3200">
+              <a:t>PERSPECTIVES &amp; INDUSTRIALISATION MLOPS</a:t>
+            </a:r>
+          </a:p>
+          <a:p>
+            <a:pPr>
+              <a:spcBef>
+                <a:spcPts val="300"/>
+              </a:spcBef>
+              <a:defRPr sz="1300">
                 <a:solidFill>
-                  <a:srgbClr val="00D2FF"/>
+                  <a:srgbClr val="94A3B8"/>
                 </a:solidFill>
-                <a:latin typeface="Calibri"/>
-                <a:ea typeface="Calibri"/>
-                <a:cs typeface="Calibri"/>
-                <a:sym typeface="Calibri"/>
-              </a:rPr>
-              <a:t> Perspectives &amp; Évolutions</a:t>
+              </a:defRPr>
+            </a:pPr>
+            <a:r>
+              <a:t>Trajectoire de Déploiement : CI/CD Automatisée, Observabilité du Drift &amp; FinOps</a:t>
             </a:r>
-            <a:endParaRPr/>
           </a:p>
         </p:txBody>
       </p:sp>
       <p:sp>
         <p:nvSpPr>
-          <p:cNvPr id="135" name="Google Shape;135;p10"/>
+          <p:cNvPr id="136" name="Rounded Rectangle 135"/>
           <p:cNvSpPr/>
           <p:nvPr/>
         </p:nvSpPr>
         <p:spPr>
           <a:xfrm>
-            <a:off x="762000" y="1524000"/>
-            <a:ext cx="5048400" cy="4381500"/>
+            <a:off x="731520" y="1463040"/>
+            <a:ext cx="3383280" cy="4389120"/>
           </a:xfrm>
           <a:prstGeom prst="roundRect">
-            <a:avLst>
-              <a:gd fmla="val 1739" name="adj"/>
-            </a:avLst>
+            <a:avLst/>
           </a:prstGeom>
           <a:solidFill>
-            <a:srgbClr val="03152B"/>
+            <a:srgbClr val="0E2A3A"/>
           </a:solidFill>
-          <a:ln cap="flat" cmpd="sng" w="14300">
+          <a:ln w="12700">
             <a:solidFill>
-              <a:srgbClr val="00D2FF"/>
+              <a:srgbClr val="16324A"/>
             </a:solidFill>
-            <a:prstDash val="solid"/>
-            <a:round/>
-            <a:headEnd len="sm" w="sm" type="none"/>
-            <a:tailEnd len="sm" w="sm" type="none"/>
           </a:ln>
         </p:spPr>
+        <p:style>
+          <a:lnRef idx="1">
+            <a:schemeClr val="accent1"/>
+          </a:lnRef>
+          <a:fillRef idx="3">
+            <a:schemeClr val="accent1"/>
+          </a:fillRef>
+          <a:effectRef idx="2">
+            <a:schemeClr val="accent1"/>
+          </a:effectRef>
+          <a:fontRef idx="minor">
+            <a:schemeClr val="lt1"/>
+          </a:fontRef>
+        </p:style>
         <p:txBody>
-          <a:bodyPr anchorCtr="0" anchor="ctr" bIns="0" lIns="0" spcFirstLastPara="1" rIns="0" wrap="square" tIns="0">
-            <a:noAutofit/>
-          </a:bodyPr>
+          <a:bodyPr rtlCol="0" anchor="ctr"/>
           <a:lstStyle/>
           <a:p>
-            <a:pPr indent="0" lvl="0" marL="0" rtl="0" algn="l">
-              <a:spcBef>
-                <a:spcPts val="0"/>
-              </a:spcBef>
-              <a:spcAft>
-                <a:spcPts val="0"/>
-              </a:spcAft>
-              <a:buNone/>
-            </a:pPr>
-            <a:r>
-              <a:t/>
-            </a:r>
-            <a:endParaRPr/>
+            <a:pPr algn="ctr"/>
           </a:p>
         </p:txBody>
       </p:sp>
       <p:sp>
         <p:nvSpPr>
-          <p:cNvPr id="136" name="Google Shape;136;p10"/>
+          <p:cNvPr id="137" name="TextBox 136"/>
           <p:cNvSpPr txBox="1"/>
           <p:nvPr/>
         </p:nvSpPr>
         <p:spPr>
           <a:xfrm>
-            <a:off x="1047750" y="1809750"/>
-            <a:ext cx="4476900" cy="3810000"/>
+            <a:off x="896112" y="1600200"/>
+            <a:ext cx="3054096" cy="4114800"/>
           </a:xfrm>
           <a:prstGeom prst="rect">
             <a:avLst/>
           </a:prstGeom>
           <a:noFill/>
-          <a:ln>
-            <a:noFill/>
-          </a:ln>
         </p:spPr>
         <p:txBody>
-          <a:bodyPr anchorCtr="0" anchor="ctr" bIns="0" lIns="0" spcFirstLastPara="1" rIns="0" wrap="square" tIns="0">
-            <a:noAutofit/>
+          <a:bodyPr wrap="square">
+            <a:spAutoFit/>
           </a:bodyPr>
           <a:lstStyle/>
           <a:p>
-            <a:pPr indent="0" lvl="0" marL="0" rtl="0" algn="l">
-              <a:spcBef>
-                <a:spcPts val="0"/>
-              </a:spcBef>
-              <a:spcAft>
-                <a:spcPts val="0"/>
-              </a:spcAft>
-              <a:buNone/>
+            <a:pPr>
+              <a:defRPr sz="950" b="1">
+                <a:solidFill>
+                  <a:srgbClr val="22D3EE"/>
+                </a:solidFill>
+              </a:defRPr>
             </a:pPr>
             <a:r>
-              <a:rPr b="1" lang="en-US" sz="2800">
-                <a:solidFill>
-                  <a:srgbClr val="00D2FF"/>
-                </a:solidFill>
-                <a:latin typeface="Calibri"/>
-                <a:ea typeface="Calibri"/>
-                <a:cs typeface="Calibri"/>
-                <a:sym typeface="Calibri"/>
-              </a:rPr>
-              <a:t>1. Intégration en Laboratoire</a:t>
+              <a:t>01 | INTÉGRATION CONTINUE (CI/CD)</a:t>
             </a:r>
-            <a:endParaRPr b="1" sz="2800">
-              <a:solidFill>
-                <a:srgbClr val="00D2FF"/>
-              </a:solidFill>
-              <a:latin typeface="Calibri"/>
-              <a:ea typeface="Calibri"/>
-              <a:cs typeface="Calibri"/>
-              <a:sym typeface="Calibri"/>
-            </a:endParaRPr>
           </a:p>
           <a:p>
-            <a:pPr indent="0" lvl="0" marL="0" rtl="0" algn="l">
-              <a:spcBef>
-                <a:spcPts val="750"/>
-              </a:spcBef>
-              <a:spcAft>
-                <a:spcPts val="0"/>
-              </a:spcAft>
-              <a:buNone/>
+            <a:pPr>
+              <a:spcBef>
+                <a:spcPts val="300"/>
+              </a:spcBef>
+              <a:spcAft>
+                <a:spcPts val="800"/>
+              </a:spcAft>
+              <a:defRPr sz="1300" b="1">
+                <a:solidFill>
+                  <a:srgbClr val="F8FAFC"/>
+                </a:solidFill>
+              </a:defRPr>
             </a:pPr>
             <a:r>
-              <a:rPr b="1" lang="en-US" sz="2200">
+              <a:t>Quality Gate &amp; Tests Automatisés</a:t>
+            </a:r>
+          </a:p>
+          <a:p>
+            <a:pPr>
+              <a:spcBef>
+                <a:spcPts val="400"/>
+              </a:spcBef>
+              <a:defRPr sz="1000" b="1">
+                <a:solidFill>
+                  <a:srgbClr val="22D3EE"/>
+                </a:solidFill>
+              </a:defRPr>
+            </a:pPr>
+            <a:r>
+              <a:t>• Pipeline GitHub Actions</a:t>
+            </a:r>
+          </a:p>
+          <a:p>
+            <a:pPr>
+              <a:spcBef>
+                <a:spcPts val="100"/>
+              </a:spcBef>
+              <a:defRPr sz="880">
                 <a:solidFill>
                   <a:srgbClr val="94A3B8"/>
                 </a:solidFill>
-                <a:latin typeface="Calibri"/>
-                <a:ea typeface="Calibri"/>
-                <a:cs typeface="Calibri"/>
-                <a:sym typeface="Calibri"/>
-              </a:rPr>
-              <a:t>Connexion Directe &amp; Automatisation</a:t>
+              </a:defRPr>
+            </a:pPr>
+            <a:r>
+              <a:t>Déclenchement automatique des contrôles qualité à chaque commit ou Pull Request.</a:t>
             </a:r>
-            <a:endParaRPr b="1" sz="2200">
-              <a:solidFill>
-                <a:srgbClr val="00D2FF"/>
-              </a:solidFill>
-              <a:latin typeface="Calibri"/>
-              <a:ea typeface="Calibri"/>
-              <a:cs typeface="Calibri"/>
-              <a:sym typeface="Calibri"/>
-            </a:endParaRPr>
           </a:p>
           <a:p>
-            <a:pPr indent="0" lvl="0" marL="0" rtl="0" algn="l">
-              <a:spcBef>
-                <a:spcPts val="1875"/>
-              </a:spcBef>
-              <a:spcAft>
-                <a:spcPts val="0"/>
-              </a:spcAft>
-              <a:buNone/>
+            <a:pPr>
+              <a:spcBef>
+                <a:spcPts val="400"/>
+              </a:spcBef>
+              <a:defRPr sz="1000" b="1">
+                <a:solidFill>
+                  <a:srgbClr val="22D3EE"/>
+                </a:solidFill>
+              </a:defRPr>
             </a:pPr>
             <a:r>
-              <a:rPr b="0" lang="en-US" sz="2050">
-                <a:solidFill>
-                  <a:srgbClr val="E2E8F0"/>
-                </a:solidFill>
-                <a:latin typeface="Calibri"/>
-                <a:ea typeface="Calibri"/>
-                <a:cs typeface="Calibri"/>
-                <a:sym typeface="Calibri"/>
-              </a:rPr>
-              <a:t>Déploiement de l'outil chez le praticien pour se connecter directement à sa base de données locale (un </a:t>
+              <a:t>• Suite PyTest Validée</a:t>
             </a:r>
-            <a:r>
-              <a:rPr b="1" lang="en-US" sz="2050">
-                <a:solidFill>
-                  <a:srgbClr val="00D2FF"/>
-                </a:solidFill>
-                <a:latin typeface="Calibri"/>
-                <a:ea typeface="Calibri"/>
-                <a:cs typeface="Calibri"/>
-                <a:sym typeface="Calibri"/>
-              </a:rPr>
-              <a:t>Gold Standard</a:t>
-            </a:r>
-            <a:r>
-              <a:rPr b="0" lang="en-US" sz="2050">
-                <a:solidFill>
-                  <a:srgbClr val="E2E8F0"/>
-                </a:solidFill>
-                <a:latin typeface="Calibri"/>
-                <a:ea typeface="Calibri"/>
-                <a:cs typeface="Calibri"/>
-                <a:sym typeface="Calibri"/>
-              </a:rPr>
-              <a:t> interne composé de PDF de patients ou de protocoles).</a:t>
-            </a:r>
-            <a:endParaRPr b="0" sz="2050">
-              <a:solidFill>
-                <a:srgbClr val="E2E8F0"/>
-              </a:solidFill>
-              <a:latin typeface="Calibri"/>
-              <a:ea typeface="Calibri"/>
-              <a:cs typeface="Calibri"/>
-              <a:sym typeface="Calibri"/>
-            </a:endParaRPr>
           </a:p>
           <a:p>
-            <a:pPr indent="0" lvl="0" marL="0" rtl="0" algn="l">
-              <a:spcBef>
-                <a:spcPts val="1125"/>
-              </a:spcBef>
-              <a:spcAft>
-                <a:spcPts val="0"/>
-              </a:spcAft>
-              <a:buNone/>
+            <a:pPr>
+              <a:spcBef>
+                <a:spcPts val="100"/>
+              </a:spcBef>
+              <a:defRPr sz="880">
+                <a:solidFill>
+                  <a:srgbClr val="94A3B8"/>
+                </a:solidFill>
+              </a:defRPr>
             </a:pPr>
             <a:r>
-              <a:rPr b="0" lang="en-US" sz="2050">
+              <a:t>9 tests unitaires et d'intégration validant le scraping, le parsing JSON et la robustesse de l'API.</a:t>
+            </a:r>
+          </a:p>
+          <a:p>
+            <a:pPr>
+              <a:spcBef>
+                <a:spcPts val="400"/>
+              </a:spcBef>
+              <a:defRPr sz="1000" b="1">
                 <a:solidFill>
-                  <a:srgbClr val="E2E8F0"/>
+                  <a:srgbClr val="22D3EE"/>
                 </a:solidFill>
-                <a:latin typeface="Calibri"/>
-                <a:ea typeface="Calibri"/>
-                <a:cs typeface="Calibri"/>
-                <a:sym typeface="Calibri"/>
-              </a:rPr>
-              <a:t>Notre pipeline </a:t>
+              </a:defRPr>
+            </a:pPr>
+            <a:r>
+              <a:t>• Conteneurisation Multi-Stage</a:t>
             </a:r>
+          </a:p>
+          <a:p>
+            <a:pPr>
+              <a:spcBef>
+                <a:spcPts val="100"/>
+              </a:spcBef>
+              <a:defRPr sz="880">
+                <a:solidFill>
+                  <a:srgbClr val="94A3B8"/>
+                </a:solidFill>
+              </a:defRPr>
+            </a:pPr>
             <a:r>
-              <a:rPr b="1" lang="en-US" sz="2050">
-                <a:solidFill>
-                  <a:srgbClr val="00D2FF"/>
-                </a:solidFill>
-                <a:latin typeface="Calibri"/>
-                <a:ea typeface="Calibri"/>
-                <a:cs typeface="Calibri"/>
-                <a:sym typeface="Calibri"/>
-              </a:rPr>
-              <a:t>NER</a:t>
+              <a:t>Images Docker ultra-légères (&lt; 500 Mo) séparant le frontend Streamlit des dépendances lourdes GPU.</a:t>
             </a:r>
-            <a:r>
-              <a:rPr b="0" lang="en-US" sz="2050">
-                <a:solidFill>
-                  <a:srgbClr val="E2E8F0"/>
-                </a:solidFill>
-                <a:latin typeface="Calibri"/>
-                <a:ea typeface="Calibri"/>
-                <a:cs typeface="Calibri"/>
-                <a:sym typeface="Calibri"/>
-              </a:rPr>
-              <a:t> automatisera l'extraction de ces données internes pour un traitement fluide et sécurisé.</a:t>
-            </a:r>
-            <a:endParaRPr b="0" sz="2050">
-              <a:solidFill>
-                <a:srgbClr val="E2E8F0"/>
-              </a:solidFill>
-              <a:latin typeface="Calibri"/>
-              <a:ea typeface="Calibri"/>
-              <a:cs typeface="Calibri"/>
-              <a:sym typeface="Calibri"/>
-            </a:endParaRPr>
           </a:p>
         </p:txBody>
       </p:sp>
       <p:sp>
         <p:nvSpPr>
-          <p:cNvPr id="137" name="Google Shape;137;p10"/>
+          <p:cNvPr id="138" name="Rounded Rectangle 137"/>
           <p:cNvSpPr/>
           <p:nvPr/>
         </p:nvSpPr>
         <p:spPr>
           <a:xfrm>
-            <a:off x="6188125" y="1524000"/>
-            <a:ext cx="5048400" cy="4381500"/>
+            <a:off x="4389120" y="1463040"/>
+            <a:ext cx="3383280" cy="4389120"/>
           </a:xfrm>
           <a:prstGeom prst="roundRect">
-            <a:avLst>
-              <a:gd fmla="val 1739" name="adj"/>
-            </a:avLst>
+            <a:avLst/>
           </a:prstGeom>
           <a:solidFill>
-            <a:srgbClr val="03152B"/>
+            <a:srgbClr val="0E2A3A"/>
           </a:solidFill>
-          <a:ln cap="flat" cmpd="sng" w="14300">
+          <a:ln w="19050">
             <a:solidFill>
-              <a:srgbClr val="00D2FF"/>
+              <a:srgbClr val="22D3EE"/>
             </a:solidFill>
-            <a:prstDash val="solid"/>
-            <a:round/>
-            <a:headEnd len="sm" w="sm" type="none"/>
-            <a:tailEnd len="sm" w="sm" type="none"/>
           </a:ln>
         </p:spPr>
+        <p:style>
+          <a:lnRef idx="1">
+            <a:schemeClr val="accent1"/>
+          </a:lnRef>
+          <a:fillRef idx="3">
+            <a:schemeClr val="accent1"/>
+          </a:fillRef>
+          <a:effectRef idx="2">
+            <a:schemeClr val="accent1"/>
+          </a:effectRef>
+          <a:fontRef idx="minor">
+            <a:schemeClr val="lt1"/>
+          </a:fontRef>
+        </p:style>
         <p:txBody>
-          <a:bodyPr anchorCtr="0" anchor="ctr" bIns="0" lIns="0" spcFirstLastPara="1" rIns="0" wrap="square" tIns="0">
-            <a:noAutofit/>
-          </a:bodyPr>
+          <a:bodyPr rtlCol="0" anchor="ctr"/>
           <a:lstStyle/>
           <a:p>
-            <a:pPr indent="0" lvl="0" marL="0" rtl="0" algn="l">
-              <a:spcBef>
-                <a:spcPts val="0"/>
-              </a:spcBef>
-              <a:spcAft>
-                <a:spcPts val="0"/>
-              </a:spcAft>
-              <a:buNone/>
-            </a:pPr>
-            <a:r>
-              <a:t/>
-            </a:r>
-            <a:endParaRPr/>
+            <a:pPr algn="ctr"/>
           </a:p>
         </p:txBody>
       </p:sp>
       <p:sp>
         <p:nvSpPr>
-          <p:cNvPr id="138" name="Google Shape;138;p10"/>
+          <p:cNvPr id="139" name="TextBox 138"/>
           <p:cNvSpPr txBox="1"/>
           <p:nvPr/>
         </p:nvSpPr>
         <p:spPr>
           <a:xfrm>
-            <a:off x="6473875" y="1630050"/>
-            <a:ext cx="4476900" cy="3989700"/>
+            <a:off x="4553712" y="1600200"/>
+            <a:ext cx="3054096" cy="4114800"/>
           </a:xfrm>
           <a:prstGeom prst="rect">
             <a:avLst/>
           </a:prstGeom>
           <a:noFill/>
-          <a:ln>
-            <a:noFill/>
-          </a:ln>
         </p:spPr>
         <p:txBody>
-          <a:bodyPr anchorCtr="0" anchor="ctr" bIns="0" lIns="0" spcFirstLastPara="1" rIns="0" wrap="square" tIns="0">
-            <a:noAutofit/>
+          <a:bodyPr wrap="square">
+            <a:spAutoFit/>
           </a:bodyPr>
           <a:lstStyle/>
           <a:p>
-            <a:pPr indent="0" lvl="0" marL="0" rtl="0" algn="l">
-              <a:spcBef>
-                <a:spcPts val="0"/>
-              </a:spcBef>
-              <a:spcAft>
-                <a:spcPts val="0"/>
-              </a:spcAft>
-              <a:buNone/>
+            <a:pPr>
+              <a:defRPr sz="950" b="1">
+                <a:solidFill>
+                  <a:srgbClr val="22D3EE"/>
+                </a:solidFill>
+              </a:defRPr>
             </a:pPr>
             <a:r>
-              <a:t/>
+              <a:t>02 | CONTINUOUS TRAINING (CT)</a:t>
             </a:r>
-            <a:endParaRPr b="1" sz="2500">
-              <a:solidFill>
-                <a:srgbClr val="00D2FF"/>
-              </a:solidFill>
-              <a:latin typeface="Calibri"/>
-              <a:ea typeface="Calibri"/>
-              <a:cs typeface="Calibri"/>
-              <a:sym typeface="Calibri"/>
-            </a:endParaRPr>
           </a:p>
           <a:p>
-            <a:pPr indent="0" lvl="0" marL="0" rtl="0" algn="l">
-              <a:spcBef>
-                <a:spcPts val="750"/>
-              </a:spcBef>
-              <a:spcAft>
-                <a:spcPts val="0"/>
-              </a:spcAft>
-              <a:buNone/>
+            <a:pPr>
+              <a:spcBef>
+                <a:spcPts val="300"/>
+              </a:spcBef>
+              <a:spcAft>
+                <a:spcPts val="800"/>
+              </a:spcAft>
+              <a:defRPr sz="1300" b="1">
+                <a:solidFill>
+                  <a:srgbClr val="F8FAFC"/>
+                </a:solidFill>
+              </a:defRPr>
             </a:pPr>
             <a:r>
-              <a:t/>
+              <a:t>Observabilité Pure &amp; Dérive Sémantique</a:t>
             </a:r>
-            <a:endParaRPr b="1" sz="2500">
-              <a:solidFill>
-                <a:srgbClr val="00D2FF"/>
-              </a:solidFill>
-              <a:latin typeface="Calibri"/>
-              <a:ea typeface="Calibri"/>
-              <a:cs typeface="Calibri"/>
-              <a:sym typeface="Calibri"/>
-            </a:endParaRPr>
           </a:p>
           <a:p>
-            <a:pPr indent="0" lvl="0" marL="0" rtl="0" algn="l">
-              <a:spcBef>
-                <a:spcPts val="750"/>
-              </a:spcBef>
-              <a:spcAft>
-                <a:spcPts val="0"/>
-              </a:spcAft>
-              <a:buNone/>
+            <a:pPr>
+              <a:spcBef>
+                <a:spcPts val="400"/>
+              </a:spcBef>
+              <a:defRPr sz="1000" b="1">
+                <a:solidFill>
+                  <a:srgbClr val="34D399"/>
+                </a:solidFill>
+              </a:defRPr>
             </a:pPr>
             <a:r>
-              <a:t/>
+              <a:t>• Détection du Drift (Wasserstein)</a:t>
             </a:r>
-            <a:endParaRPr b="1" sz="2500">
-              <a:solidFill>
-                <a:srgbClr val="00D2FF"/>
-              </a:solidFill>
-              <a:latin typeface="Calibri"/>
-              <a:ea typeface="Calibri"/>
-              <a:cs typeface="Calibri"/>
-              <a:sym typeface="Calibri"/>
-            </a:endParaRPr>
           </a:p>
           <a:p>
-            <a:pPr indent="0" lvl="0" marL="0" rtl="0" algn="l">
-              <a:spcBef>
-                <a:spcPts val="750"/>
-              </a:spcBef>
-              <a:spcAft>
-                <a:spcPts val="0"/>
-              </a:spcAft>
-              <a:buNone/>
+            <a:pPr>
+              <a:spcBef>
+                <a:spcPts val="100"/>
+              </a:spcBef>
+              <a:defRPr sz="880">
+                <a:solidFill>
+                  <a:srgbClr val="94A3B8"/>
+                </a:solidFill>
+              </a:defRPr>
             </a:pPr>
             <a:r>
-              <a:rPr b="1" lang="en-US" sz="2500">
-                <a:solidFill>
-                  <a:srgbClr val="00D2FF"/>
-                </a:solidFill>
-                <a:latin typeface="Calibri"/>
-                <a:ea typeface="Calibri"/>
-                <a:cs typeface="Calibri"/>
-                <a:sym typeface="Calibri"/>
-              </a:rPr>
-              <a:t>2. Améliorations Techniques</a:t>
+              <a:t>Calcul continu de la distance statistique sur les embeddings vectoriels avec seuil d'alerte strict fixé à 0.08.</a:t>
             </a:r>
-            <a:endParaRPr b="1" sz="2500">
-              <a:solidFill>
-                <a:srgbClr val="00D2FF"/>
-              </a:solidFill>
-              <a:latin typeface="Calibri"/>
-              <a:ea typeface="Calibri"/>
-              <a:cs typeface="Calibri"/>
-              <a:sym typeface="Calibri"/>
-            </a:endParaRPr>
           </a:p>
           <a:p>
-            <a:pPr indent="0" lvl="0" marL="0" rtl="0" algn="l">
-              <a:spcBef>
-                <a:spcPts val="750"/>
-              </a:spcBef>
-              <a:spcAft>
-                <a:spcPts val="0"/>
-              </a:spcAft>
-              <a:buNone/>
+            <a:pPr>
+              <a:spcBef>
+                <a:spcPts val="400"/>
+              </a:spcBef>
+              <a:defRPr sz="1000" b="1">
+                <a:solidFill>
+                  <a:srgbClr val="34D399"/>
+                </a:solidFill>
+              </a:defRPr>
             </a:pPr>
             <a:r>
-              <a:rPr b="1" lang="en-US" sz="1700">
-                <a:solidFill>
-                  <a:srgbClr val="00D2FF"/>
-                </a:solidFill>
-                <a:latin typeface="Calibri"/>
-                <a:ea typeface="Calibri"/>
-                <a:cs typeface="Calibri"/>
-                <a:sym typeface="Calibri"/>
-              </a:rPr>
-              <a:t>• Benchmark avec l’état de l’art </a:t>
+              <a:t>• Réentraînement LoRA Déclenché</a:t>
             </a:r>
-            <a:r>
-              <a:rPr lang="en-US" sz="1700">
-                <a:solidFill>
-                  <a:srgbClr val="E2E8F0"/>
-                </a:solidFill>
-                <a:latin typeface="Calibri"/>
-                <a:ea typeface="Calibri"/>
-                <a:cs typeface="Calibri"/>
-                <a:sym typeface="Calibri"/>
-              </a:rPr>
-              <a:t>: quel est le standard actuel, peut-on faire mieux ?</a:t>
-            </a:r>
-            <a:endParaRPr sz="1700">
-              <a:solidFill>
-                <a:srgbClr val="E2E8F0"/>
-              </a:solidFill>
-              <a:latin typeface="Calibri"/>
-              <a:ea typeface="Calibri"/>
-              <a:cs typeface="Calibri"/>
-              <a:sym typeface="Calibri"/>
-            </a:endParaRPr>
           </a:p>
           <a:p>
-            <a:pPr indent="0" lvl="0" marL="0" rtl="0" algn="l">
-              <a:spcBef>
-                <a:spcPts val="900"/>
-              </a:spcBef>
-              <a:spcAft>
-                <a:spcPts val="0"/>
-              </a:spcAft>
-              <a:buClr>
-                <a:schemeClr val="dk1"/>
-              </a:buClr>
-              <a:buSzPts val="1100"/>
-              <a:buFont typeface="Arial"/>
-              <a:buNone/>
+            <a:pPr>
+              <a:spcBef>
+                <a:spcPts val="100"/>
+              </a:spcBef>
+              <a:defRPr sz="880">
+                <a:solidFill>
+                  <a:srgbClr val="94A3B8"/>
+                </a:solidFill>
+              </a:defRPr>
             </a:pPr>
             <a:r>
-              <a:rPr b="1" lang="en-US" sz="1700">
-                <a:solidFill>
-                  <a:srgbClr val="00D2FF"/>
-                </a:solidFill>
-                <a:latin typeface="Calibri"/>
-                <a:ea typeface="Calibri"/>
-                <a:cs typeface="Calibri"/>
-                <a:sym typeface="Calibri"/>
-              </a:rPr>
-              <a:t>• Trade-off</a:t>
+              <a:t>Réentraînement automatique sur instance GPU dès qu'une dérive sémantique significative est identifiée.</a:t>
             </a:r>
-            <a:r>
-              <a:rPr lang="en-US" sz="1700">
-                <a:solidFill>
-                  <a:srgbClr val="E2E8F0"/>
-                </a:solidFill>
-                <a:latin typeface="Calibri"/>
-                <a:ea typeface="Calibri"/>
-                <a:cs typeface="Calibri"/>
-                <a:sym typeface="Calibri"/>
-              </a:rPr>
-              <a:t> performance vs taille modèles à trouver</a:t>
-            </a:r>
-            <a:endParaRPr sz="1700">
-              <a:solidFill>
-                <a:srgbClr val="E2E8F0"/>
-              </a:solidFill>
-              <a:latin typeface="Calibri"/>
-              <a:ea typeface="Calibri"/>
-              <a:cs typeface="Calibri"/>
-              <a:sym typeface="Calibri"/>
-            </a:endParaRPr>
           </a:p>
           <a:p>
-            <a:pPr indent="0" lvl="0" marL="0" rtl="0" algn="l">
-              <a:spcBef>
-                <a:spcPts val="900"/>
-              </a:spcBef>
-              <a:spcAft>
-                <a:spcPts val="0"/>
-              </a:spcAft>
-              <a:buNone/>
+            <a:pPr>
+              <a:spcBef>
+                <a:spcPts val="400"/>
+              </a:spcBef>
+              <a:defRPr sz="1000" b="1">
+                <a:solidFill>
+                  <a:srgbClr val="34D399"/>
+                </a:solidFill>
+              </a:defRPr>
             </a:pPr>
             <a:r>
-              <a:rPr b="1" lang="en-US" sz="1700">
-                <a:solidFill>
-                  <a:srgbClr val="00D2FF"/>
-                </a:solidFill>
-                <a:latin typeface="Calibri"/>
-                <a:ea typeface="Calibri"/>
-                <a:cs typeface="Calibri"/>
-                <a:sym typeface="Calibri"/>
-              </a:rPr>
-              <a:t>• Auto-suppression Supabase :</a:t>
+              <a:t>• Télémétrie MLflow Cloud Run</a:t>
             </a:r>
-            <a:r>
-              <a:rPr lang="en-US" sz="1700">
-                <a:solidFill>
-                  <a:srgbClr val="E2E8F0"/>
-                </a:solidFill>
-                <a:latin typeface="Calibri"/>
-                <a:ea typeface="Calibri"/>
-                <a:cs typeface="Calibri"/>
-                <a:sym typeface="Calibri"/>
-              </a:rPr>
-              <a:t> CRON/TTL pour purger les PDF temporaires et optimiser les coûts.</a:t>
-            </a:r>
-            <a:endParaRPr sz="1700">
-              <a:solidFill>
-                <a:srgbClr val="E2E8F0"/>
-              </a:solidFill>
-              <a:latin typeface="Calibri"/>
-              <a:ea typeface="Calibri"/>
-              <a:cs typeface="Calibri"/>
-              <a:sym typeface="Calibri"/>
-            </a:endParaRPr>
           </a:p>
           <a:p>
-            <a:pPr indent="0" lvl="0" marL="0" rtl="0" algn="l">
-              <a:spcBef>
-                <a:spcPts val="900"/>
-              </a:spcBef>
-              <a:spcAft>
-                <a:spcPts val="0"/>
-              </a:spcAft>
-              <a:buNone/>
+            <a:pPr>
+              <a:spcBef>
+                <a:spcPts val="100"/>
+              </a:spcBef>
+              <a:defRPr sz="880">
+                <a:solidFill>
+                  <a:srgbClr val="94A3B8"/>
+                </a:solidFill>
+              </a:defRPr>
             </a:pPr>
             <a:r>
-              <a:rPr b="1" lang="en-US" sz="1700">
+              <a:t>Tracking temps réel des métriques (latence, F1, cache-hits) hébergé 24h/24 sans stockage de données patient (Privacy by Design).</a:t>
+            </a:r>
+          </a:p>
+        </p:txBody>
+      </p:sp>
+      <p:sp>
+        <p:nvSpPr>
+          <p:cNvPr id="140" name="Rounded Rectangle 139"/>
+          <p:cNvSpPr/>
+          <p:nvPr/>
+        </p:nvSpPr>
+        <p:spPr>
+          <a:xfrm>
+            <a:off x="8046720" y="1463040"/>
+            <a:ext cx="3383280" cy="4389120"/>
+          </a:xfrm>
+          <a:prstGeom prst="roundRect">
+            <a:avLst/>
+          </a:prstGeom>
+          <a:solidFill>
+            <a:srgbClr val="0E2A3A"/>
+          </a:solidFill>
+          <a:ln w="12700">
+            <a:solidFill>
+              <a:srgbClr val="16324A"/>
+            </a:solidFill>
+          </a:ln>
+        </p:spPr>
+        <p:style>
+          <a:lnRef idx="1">
+            <a:schemeClr val="accent1"/>
+          </a:lnRef>
+          <a:fillRef idx="3">
+            <a:schemeClr val="accent1"/>
+          </a:fillRef>
+          <a:effectRef idx="2">
+            <a:schemeClr val="accent1"/>
+          </a:effectRef>
+          <a:fontRef idx="minor">
+            <a:schemeClr val="lt1"/>
+          </a:fontRef>
+        </p:style>
+        <p:txBody>
+          <a:bodyPr rtlCol="0" anchor="ctr"/>
+          <a:lstStyle/>
+          <a:p>
+            <a:pPr algn="ctr"/>
+          </a:p>
+        </p:txBody>
+      </p:sp>
+      <p:sp>
+        <p:nvSpPr>
+          <p:cNvPr id="141" name="TextBox 140"/>
+          <p:cNvSpPr txBox="1"/>
+          <p:nvPr/>
+        </p:nvSpPr>
+        <p:spPr>
+          <a:xfrm>
+            <a:off x="8211312" y="1600200"/>
+            <a:ext cx="3054096" cy="4114800"/>
+          </a:xfrm>
+          <a:prstGeom prst="rect">
+            <a:avLst/>
+          </a:prstGeom>
+          <a:noFill/>
+        </p:spPr>
+        <p:txBody>
+          <a:bodyPr wrap="square">
+            <a:spAutoFit/>
+          </a:bodyPr>
+          <a:lstStyle/>
+          <a:p>
+            <a:pPr>
+              <a:defRPr sz="950" b="1">
                 <a:solidFill>
-                  <a:srgbClr val="00D2FF"/>
+                  <a:srgbClr val="22D3EE"/>
                 </a:solidFill>
-                <a:latin typeface="Calibri"/>
-                <a:ea typeface="Calibri"/>
-                <a:cs typeface="Calibri"/>
-                <a:sym typeface="Calibri"/>
-              </a:rPr>
-              <a:t>• Scalabilité &amp; SLM :</a:t>
+              </a:defRPr>
+            </a:pPr>
+            <a:r>
+              <a:t>03 | FINOPS &amp; SOUVERAINETÉ</a:t>
             </a:r>
-            <a:r>
-              <a:rPr b="0" lang="en-US" sz="1700">
-                <a:solidFill>
-                  <a:srgbClr val="E2E8F0"/>
-                </a:solidFill>
-                <a:latin typeface="Calibri"/>
-                <a:ea typeface="Calibri"/>
-                <a:cs typeface="Calibri"/>
-                <a:sym typeface="Calibri"/>
-              </a:rPr>
-              <a:t> </a:t>
-            </a:r>
-            <a:r>
-              <a:rPr lang="en-US" sz="1700">
-                <a:solidFill>
-                  <a:srgbClr val="E2E8F0"/>
-                </a:solidFill>
-                <a:latin typeface="Calibri"/>
-                <a:ea typeface="Calibri"/>
-                <a:cs typeface="Calibri"/>
-                <a:sym typeface="Calibri"/>
-              </a:rPr>
-              <a:t>Déploiement local sur les serveurs internes des hôpitaux/labos. Cela garantit la protection du secret industriel pour les protocoles non publiés, et assure que les données patients ne sortent jamais sur Internet</a:t>
-            </a:r>
-            <a:endParaRPr sz="1700">
-              <a:solidFill>
-                <a:srgbClr val="E2E8F0"/>
-              </a:solidFill>
-              <a:latin typeface="Calibri"/>
-              <a:ea typeface="Calibri"/>
-              <a:cs typeface="Calibri"/>
-              <a:sym typeface="Calibri"/>
-            </a:endParaRPr>
           </a:p>
           <a:p>
-            <a:pPr indent="0" lvl="0" marL="0" rtl="0" algn="l">
-              <a:spcBef>
-                <a:spcPts val="0"/>
-              </a:spcBef>
-              <a:spcAft>
-                <a:spcPts val="0"/>
-              </a:spcAft>
-              <a:buNone/>
+            <a:pPr>
+              <a:spcBef>
+                <a:spcPts val="300"/>
+              </a:spcBef>
+              <a:spcAft>
+                <a:spcPts val="800"/>
+              </a:spcAft>
+              <a:defRPr sz="1300" b="1">
+                <a:solidFill>
+                  <a:srgbClr val="F8FAFC"/>
+                </a:solidFill>
+              </a:defRPr>
             </a:pPr>
             <a:r>
-              <a:t/>
+              <a:t>Contrôle des Coûts &amp; Secret Industriel</a:t>
             </a:r>
-            <a:endParaRPr sz="1700">
-              <a:solidFill>
-                <a:srgbClr val="E2E8F0"/>
-              </a:solidFill>
-              <a:latin typeface="Calibri"/>
-              <a:ea typeface="Calibri"/>
-              <a:cs typeface="Calibri"/>
-              <a:sym typeface="Calibri"/>
-            </a:endParaRPr>
           </a:p>
           <a:p>
-            <a:pPr indent="0" lvl="0" marL="0" rtl="0" algn="l">
-              <a:spcBef>
-                <a:spcPts val="0"/>
-              </a:spcBef>
-              <a:spcAft>
-                <a:spcPts val="0"/>
-              </a:spcAft>
-              <a:buNone/>
+            <a:pPr>
+              <a:spcBef>
+                <a:spcPts val="400"/>
+              </a:spcBef>
+              <a:defRPr sz="1000" b="1">
+                <a:solidFill>
+                  <a:srgbClr val="22D3EE"/>
+                </a:solidFill>
+              </a:defRPr>
             </a:pPr>
             <a:r>
-              <a:t/>
+              <a:t>• Auto-Kill AWS EC2 (Boto3)</a:t>
             </a:r>
-            <a:endParaRPr sz="1700">
-              <a:solidFill>
-                <a:srgbClr val="E2E8F0"/>
-              </a:solidFill>
-              <a:latin typeface="Calibri"/>
-              <a:ea typeface="Calibri"/>
-              <a:cs typeface="Calibri"/>
-              <a:sym typeface="Calibri"/>
-            </a:endParaRPr>
           </a:p>
           <a:p>
-            <a:pPr indent="0" lvl="0" marL="0" rtl="0" algn="l">
-              <a:spcBef>
-                <a:spcPts val="0"/>
-              </a:spcBef>
-              <a:spcAft>
-                <a:spcPts val="0"/>
-              </a:spcAft>
-              <a:buNone/>
+            <a:pPr>
+              <a:spcBef>
+                <a:spcPts val="100"/>
+              </a:spcBef>
+              <a:defRPr sz="880">
+                <a:solidFill>
+                  <a:srgbClr val="94A3B8"/>
+                </a:solidFill>
+              </a:defRPr>
             </a:pPr>
             <a:r>
-              <a:t/>
+              <a:t>Arrêt programmable de la machine GPU physique dès l'inactivité pour éliminer tout gaspillage budgétaire.</a:t>
             </a:r>
-            <a:endParaRPr sz="1700">
-              <a:solidFill>
-                <a:srgbClr val="E2E8F0"/>
-              </a:solidFill>
-              <a:latin typeface="Calibri"/>
-              <a:ea typeface="Calibri"/>
-              <a:cs typeface="Calibri"/>
-              <a:sym typeface="Calibri"/>
-            </a:endParaRPr>
           </a:p>
           <a:p>
-            <a:pPr indent="0" lvl="0" marL="0" rtl="0" algn="l">
-              <a:spcBef>
-                <a:spcPts val="0"/>
-              </a:spcBef>
-              <a:spcAft>
-                <a:spcPts val="0"/>
-              </a:spcAft>
-              <a:buNone/>
+            <a:pPr>
+              <a:spcBef>
+                <a:spcPts val="400"/>
+              </a:spcBef>
+              <a:defRPr sz="1000" b="1">
+                <a:solidFill>
+                  <a:srgbClr val="22D3EE"/>
+                </a:solidFill>
+              </a:defRPr>
             </a:pPr>
             <a:r>
-              <a:t/>
+              <a:t>• Déploiement Sur-Site (On-Premise)</a:t>
             </a:r>
-            <a:endParaRPr sz="1700">
-              <a:solidFill>
-                <a:srgbClr val="E2E8F0"/>
-              </a:solidFill>
-              <a:latin typeface="Calibri"/>
-              <a:ea typeface="Calibri"/>
-              <a:cs typeface="Calibri"/>
-              <a:sym typeface="Calibri"/>
-            </a:endParaRPr>
           </a:p>
           <a:p>
-            <a:pPr indent="0" lvl="0" marL="0" rtl="0" algn="l">
-              <a:spcBef>
-                <a:spcPts val="0"/>
-              </a:spcBef>
-              <a:spcAft>
-                <a:spcPts val="0"/>
-              </a:spcAft>
-              <a:buNone/>
+            <a:pPr>
+              <a:spcBef>
+                <a:spcPts val="100"/>
+              </a:spcBef>
+              <a:defRPr sz="880">
+                <a:solidFill>
+                  <a:srgbClr val="94A3B8"/>
+                </a:solidFill>
+              </a:defRPr>
             </a:pPr>
             <a:r>
-              <a:t/>
+              <a:t>Possibilité de serving local sur serveurs hospitaliers : aucune donnée médicale sensible ne quitte le réseau interne.</a:t>
             </a:r>
-            <a:endParaRPr sz="1700">
-              <a:solidFill>
-                <a:srgbClr val="E2E8F0"/>
-              </a:solidFill>
-              <a:latin typeface="Calibri"/>
-              <a:ea typeface="Calibri"/>
-              <a:cs typeface="Calibri"/>
-              <a:sym typeface="Calibri"/>
-            </a:endParaRPr>
+          </a:p>
+          <a:p>
+            <a:pPr>
+              <a:spcBef>
+                <a:spcPts val="400"/>
+              </a:spcBef>
+              <a:defRPr sz="1000" b="1">
+                <a:solidFill>
+                  <a:srgbClr val="22D3EE"/>
+                </a:solidFill>
+              </a:defRPr>
+            </a:pPr>
+            <a:r>
+              <a:t>• Cache Persistant Supabase</a:t>
+            </a:r>
+          </a:p>
+          <a:p>
+            <a:pPr>
+              <a:spcBef>
+                <a:spcPts val="100"/>
+              </a:spcBef>
+              <a:defRPr sz="880">
+                <a:solidFill>
+                  <a:srgbClr val="94A3B8"/>
+                </a:solidFill>
+              </a:defRPr>
+            </a:pPr>
+            <a:r>
+              <a:t>40% des requêtes répétées servies en 0,2s à coût GPU nul grâce à la table clinical_ner_cache.</a:t>
+            </a:r>
           </a:p>
         </p:txBody>
       </p:sp>

</xml_diff>

<commit_message>
feat(certif): harmonisation complete des livrables des blocs 1 a 6 conformes aux attentes Jedha
</commit_message>
<xml_diff>
--- a/Bloc_6_CliNER/CliNER_presentation.pptx
+++ b/Bloc_6_CliNER/CliNER_presentation.pptx
@@ -15116,7 +15116,7 @@
         <p:spPr>
           <a:xfrm>
             <a:off x="762000" y="762000"/>
-            <a:ext cx="4953000" cy="2889900"/>
+            <a:ext cx="4953000" cy="5722200"/>
           </a:xfrm>
           <a:prstGeom prst="rect">
             <a:avLst/>
@@ -15210,7 +15210,53 @@
               <a:buNone/>
             </a:pPr>
             <a:r>
-              <a:rPr b="0" lang="en-US" sz="3800">
+              <a:t/>
+            </a:r>
+            <a:endParaRPr sz="1100">
+              <a:solidFill>
+                <a:srgbClr val="64748B"/>
+              </a:solidFill>
+              <a:latin typeface="Montserrat SemiBold"/>
+              <a:ea typeface="Montserrat SemiBold"/>
+              <a:cs typeface="Montserrat SemiBold"/>
+              <a:sym typeface="Montserrat SemiBold"/>
+            </a:endParaRPr>
+          </a:p>
+          <a:p>
+            <a:pPr indent="0" lvl="0" marL="0" rtl="0" algn="l">
+              <a:spcBef>
+                <a:spcPts val="2400"/>
+              </a:spcBef>
+              <a:spcAft>
+                <a:spcPts val="0"/>
+              </a:spcAft>
+              <a:buNone/>
+            </a:pPr>
+            <a:r>
+              <a:t/>
+            </a:r>
+            <a:endParaRPr sz="1100">
+              <a:solidFill>
+                <a:srgbClr val="64748B"/>
+              </a:solidFill>
+              <a:latin typeface="Montserrat SemiBold"/>
+              <a:ea typeface="Montserrat SemiBold"/>
+              <a:cs typeface="Montserrat SemiBold"/>
+              <a:sym typeface="Montserrat SemiBold"/>
+            </a:endParaRPr>
+          </a:p>
+          <a:p>
+            <a:pPr indent="0" lvl="0" marL="0" rtl="0" algn="ctr">
+              <a:spcBef>
+                <a:spcPts val="2400"/>
+              </a:spcBef>
+              <a:spcAft>
+                <a:spcPts val="0"/>
+              </a:spcAft>
+              <a:buNone/>
+            </a:pPr>
+            <a:r>
+              <a:rPr b="0" lang="en-US" sz="4100">
                 <a:solidFill>
                   <a:srgbClr val="00D2FF"/>
                 </a:solidFill>
@@ -15221,7 +15267,7 @@
               </a:rPr>
               <a:t>CliNER</a:t>
             </a:r>
-            <a:endParaRPr b="0" sz="3800">
+            <a:endParaRPr b="0" sz="4100">
               <a:solidFill>
                 <a:srgbClr val="00D2FF"/>
               </a:solidFill>
@@ -15232,7 +15278,7 @@
             </a:endParaRPr>
           </a:p>
           <a:p>
-            <a:pPr indent="0" lvl="0" marL="0" rtl="0" algn="l">
+            <a:pPr indent="0" lvl="0" marL="0" rtl="0" algn="ctr">
               <a:spcBef>
                 <a:spcPts val="900"/>
               </a:spcBef>
@@ -15242,7 +15288,7 @@
               <a:buNone/>
             </a:pPr>
             <a:r>
-              <a:rPr b="1" lang="en-US" sz="2000">
+              <a:rPr b="1" lang="en-US" sz="2300">
                 <a:solidFill>
                   <a:srgbClr val="FFFFFF"/>
                 </a:solidFill>
@@ -15252,6 +15298,52 @@
                 <a:sym typeface="Montserrat"/>
               </a:rPr>
               <a:t>Extraction d’Entités Médicales (NER) par LLM Fine-Tuné &amp; RAG Hybride</a:t>
+            </a:r>
+            <a:endParaRPr b="1" sz="2300">
+              <a:solidFill>
+                <a:srgbClr val="FFFFFF"/>
+              </a:solidFill>
+              <a:latin typeface="Montserrat"/>
+              <a:ea typeface="Montserrat"/>
+              <a:cs typeface="Montserrat"/>
+              <a:sym typeface="Montserrat"/>
+            </a:endParaRPr>
+          </a:p>
+          <a:p>
+            <a:pPr indent="0" lvl="0" marL="0" rtl="0" algn="l">
+              <a:spcBef>
+                <a:spcPts val="3000"/>
+              </a:spcBef>
+              <a:spcAft>
+                <a:spcPts val="0"/>
+              </a:spcAft>
+              <a:buNone/>
+            </a:pPr>
+            <a:r>
+              <a:t/>
+            </a:r>
+            <a:endParaRPr b="1" sz="2000">
+              <a:solidFill>
+                <a:srgbClr val="FFFFFF"/>
+              </a:solidFill>
+              <a:latin typeface="Montserrat"/>
+              <a:ea typeface="Montserrat"/>
+              <a:cs typeface="Montserrat"/>
+              <a:sym typeface="Montserrat"/>
+            </a:endParaRPr>
+          </a:p>
+          <a:p>
+            <a:pPr indent="0" lvl="0" marL="0" rtl="0" algn="l">
+              <a:spcBef>
+                <a:spcPts val="3000"/>
+              </a:spcBef>
+              <a:spcAft>
+                <a:spcPts val="0"/>
+              </a:spcAft>
+              <a:buNone/>
+            </a:pPr>
+            <a:r>
+              <a:t/>
             </a:r>
             <a:endParaRPr b="1" sz="2000">
               <a:solidFill>
@@ -15535,7 +15627,7 @@
                 <a:buNone/>
               </a:pPr>
               <a:r>
-                <a:rPr b="1" lang="en-US" sz="2000">
+                <a:rPr b="1" lang="en-US" sz="2300">
                   <a:solidFill>
                     <a:srgbClr val="FF6B6B"/>
                   </a:solidFill>
@@ -15546,7 +15638,7 @@
                 </a:rPr>
                 <a:t>⚠️ Le Chaos Médical</a:t>
               </a:r>
-              <a:endParaRPr b="1" sz="2000">
+              <a:endParaRPr b="1" sz="2300">
                 <a:solidFill>
                   <a:srgbClr val="FF6B6B"/>
                 </a:solidFill>
@@ -15567,7 +15659,7 @@
                 <a:buNone/>
               </a:pPr>
               <a:r>
-                <a:rPr b="1" lang="en-US" sz="1200">
+                <a:rPr b="1" lang="en-US" sz="1500">
                   <a:solidFill>
                     <a:srgbClr val="FF6B6B"/>
                   </a:solidFill>
@@ -15579,7 +15671,7 @@
                 <a:t>Objectif :</a:t>
               </a:r>
               <a:r>
-                <a:rPr lang="en-US" sz="1200">
+                <a:rPr lang="en-US" sz="1500">
                   <a:solidFill>
                     <a:srgbClr val="F1F5F9"/>
                   </a:solidFill>
@@ -15590,7 +15682,7 @@
                 </a:rPr>
                 <a:t> Comparer efficacement des essais cliniques</a:t>
               </a:r>
-              <a:endParaRPr sz="1200">
+              <a:endParaRPr sz="1500">
                 <a:solidFill>
                   <a:srgbClr val="F1F5F9"/>
                 </a:solidFill>
@@ -15611,7 +15703,7 @@
                 <a:buNone/>
               </a:pPr>
               <a:r>
-                <a:rPr b="1" lang="en-US" sz="1300">
+                <a:rPr b="1" lang="en-US" sz="1600">
                   <a:solidFill>
                     <a:srgbClr val="F1F5F9"/>
                   </a:solidFill>
@@ -15622,7 +15714,7 @@
                 </a:rPr>
                 <a:t>Données officielles hétérogènes</a:t>
               </a:r>
-              <a:endParaRPr b="1" sz="1300">
+              <a:endParaRPr b="1" sz="1600">
                 <a:solidFill>
                   <a:srgbClr val="F1F5F9"/>
                 </a:solidFill>
@@ -15643,7 +15735,7 @@
                 <a:buNone/>
               </a:pPr>
               <a:r>
-                <a:rPr lang="en-US" sz="1100">
+                <a:rPr lang="en-US">
                   <a:solidFill>
                     <a:srgbClr val="CBD5E1"/>
                   </a:solidFill>
@@ -15654,7 +15746,7 @@
                 </a:rPr>
                 <a:t>ClinicalTrials fournit des JSON incomplets et non structurés.</a:t>
               </a:r>
-              <a:endParaRPr sz="1100">
+              <a:endParaRPr>
                 <a:solidFill>
                   <a:srgbClr val="CBD5E1"/>
                 </a:solidFill>
@@ -15675,7 +15767,7 @@
                 <a:buNone/>
               </a:pPr>
               <a:r>
-                <a:rPr b="1" lang="en-US" sz="1300">
+                <a:rPr b="1" lang="en-US" sz="1600">
                   <a:solidFill>
                     <a:srgbClr val="F1F5F9"/>
                   </a:solidFill>
@@ -15686,7 +15778,7 @@
                 </a:rPr>
                 <a:t>Information noyée</a:t>
               </a:r>
-              <a:endParaRPr b="1" sz="1300">
+              <a:endParaRPr b="1" sz="1600">
                 <a:solidFill>
                   <a:srgbClr val="F1F5F9"/>
                 </a:solidFill>
@@ -15707,7 +15799,7 @@
                 <a:buNone/>
               </a:pPr>
               <a:r>
-                <a:rPr lang="en-US" sz="1100">
+                <a:rPr lang="en-US">
                   <a:solidFill>
                     <a:srgbClr val="CBD5E1"/>
                   </a:solidFill>
@@ -15718,7 +15810,7 @@
                 </a:rPr>
                 <a:t>L'information cruciale est enfouie dans des documents PDF de 100 à 200 pages.</a:t>
               </a:r>
-              <a:endParaRPr sz="1100">
+              <a:endParaRPr>
                 <a:solidFill>
                   <a:srgbClr val="CBD5E1"/>
                 </a:solidFill>
@@ -15739,7 +15831,7 @@
                 <a:buNone/>
               </a:pPr>
               <a:r>
-                <a:rPr b="1" lang="en-US" sz="1300">
+                <a:rPr b="1" lang="en-US" sz="1600">
                   <a:solidFill>
                     <a:srgbClr val="FF6B6B"/>
                   </a:solidFill>
@@ -15750,7 +15842,7 @@
                 </a:rPr>
                 <a:t>Incomparabilité des essais</a:t>
               </a:r>
-              <a:endParaRPr b="1" sz="1300">
+              <a:endParaRPr b="1" sz="1600">
                 <a:solidFill>
                   <a:srgbClr val="FF6B6B"/>
                 </a:solidFill>
@@ -15771,7 +15863,7 @@
                 <a:buNone/>
               </a:pPr>
               <a:r>
-                <a:rPr lang="en-US" sz="1100">
+                <a:rPr lang="en-US">
                   <a:solidFill>
                     <a:srgbClr val="CBD5E1"/>
                   </a:solidFill>
@@ -15782,7 +15874,7 @@
                 </a:rPr>
                 <a:t>Impossible de vérifier si 2 essais sur un même médicament partagent des conditions comparables.</a:t>
               </a:r>
-              <a:endParaRPr sz="1100">
+              <a:endParaRPr>
                 <a:solidFill>
                   <a:srgbClr val="CBD5E1"/>
                 </a:solidFill>
@@ -15895,7 +15987,7 @@
                 <a:buNone/>
               </a:pPr>
               <a:r>
-                <a:rPr b="1" lang="en-US" sz="2000">
+                <a:rPr b="1" lang="en-US" sz="2300">
                   <a:solidFill>
                     <a:srgbClr val="00D2FF"/>
                   </a:solidFill>
@@ -15906,7 +15998,7 @@
                 </a:rPr>
                 <a:t>🚀 La Solution (MVP)</a:t>
               </a:r>
-              <a:endParaRPr b="1" sz="2000">
+              <a:endParaRPr b="1" sz="2300">
                 <a:solidFill>
                   <a:srgbClr val="00D2FF"/>
                 </a:solidFill>
@@ -15927,7 +16019,7 @@
                 <a:buNone/>
               </a:pPr>
               <a:r>
-                <a:rPr b="1" lang="en-US" sz="1200">
+                <a:rPr b="1" lang="en-US" sz="1500">
                   <a:solidFill>
                     <a:srgbClr val="00D2FF"/>
                   </a:solidFill>
@@ -15938,7 +16030,7 @@
                 </a:rPr>
                 <a:t>NER (Qwen Fine-Tuné)</a:t>
               </a:r>
-              <a:endParaRPr b="1" sz="1200">
+              <a:endParaRPr b="1" sz="1500">
                 <a:solidFill>
                   <a:srgbClr val="00D2FF"/>
                 </a:solidFill>
@@ -15959,7 +16051,7 @@
                 <a:buNone/>
               </a:pPr>
               <a:r>
-                <a:rPr lang="en-US" sz="1050">
+                <a:rPr lang="en-US" sz="1350">
                   <a:solidFill>
                     <a:srgbClr val="F1F5F9"/>
                   </a:solidFill>
@@ -15970,7 +16062,7 @@
                 </a:rPr>
                 <a:t>Extraction d'informations médicales standardisées &amp; filtres</a:t>
               </a:r>
-              <a:endParaRPr sz="1050">
+              <a:endParaRPr sz="1350">
                 <a:solidFill>
                   <a:srgbClr val="F1F5F9"/>
                 </a:solidFill>
@@ -15991,7 +16083,7 @@
                 <a:buNone/>
               </a:pPr>
               <a:r>
-                <a:rPr b="1" lang="en-US" sz="1200">
+                <a:rPr b="1" lang="en-US" sz="1500">
                   <a:solidFill>
                     <a:srgbClr val="00D2FF"/>
                   </a:solidFill>
@@ -16002,7 +16094,7 @@
                 </a:rPr>
                 <a:t>Recherche Augmentée (RAG BioBERT)</a:t>
               </a:r>
-              <a:endParaRPr b="1" sz="1200">
+              <a:endParaRPr b="1" sz="1500">
                 <a:solidFill>
                   <a:srgbClr val="00D2FF"/>
                 </a:solidFill>
@@ -16023,7 +16115,7 @@
                 <a:buNone/>
               </a:pPr>
               <a:r>
-                <a:rPr lang="en-US" sz="1050">
+                <a:rPr lang="en-US" sz="1350">
                   <a:solidFill>
                     <a:srgbClr val="F1F5F9"/>
                   </a:solidFill>
@@ -16034,7 +16126,7 @@
                 </a:rPr>
                 <a:t>Interrogation instantanée des protocoles cliniques en langage naturel</a:t>
               </a:r>
-              <a:endParaRPr sz="1050">
+              <a:endParaRPr sz="1350">
                 <a:solidFill>
                   <a:srgbClr val="F1F5F9"/>
                 </a:solidFill>
@@ -16055,7 +16147,7 @@
                 <a:buNone/>
               </a:pPr>
               <a:r>
-                <a:rPr b="1" lang="en-US" sz="1200">
+                <a:rPr b="1" lang="en-US" sz="1500">
                   <a:solidFill>
                     <a:srgbClr val="00D2FF"/>
                   </a:solidFill>
@@ -16066,7 +16158,7 @@
                 </a:rPr>
                 <a:t>Gold Standard (Chia Dataset)</a:t>
               </a:r>
-              <a:endParaRPr b="1" sz="1200">
+              <a:endParaRPr b="1" sz="1500">
                 <a:solidFill>
                   <a:srgbClr val="00D2FF"/>
                 </a:solidFill>
@@ -16087,7 +16179,7 @@
                 <a:buNone/>
               </a:pPr>
               <a:r>
-                <a:rPr lang="en-US" sz="1050">
+                <a:rPr lang="en-US" sz="1350">
                   <a:solidFill>
                     <a:srgbClr val="CBD5E1"/>
                   </a:solidFill>
@@ -16098,7 +16190,7 @@
                 </a:rPr>
                 <a:t>1 000 études annotées (144 avec PDF), réparties en Train &amp; Test sets</a:t>
               </a:r>
-              <a:endParaRPr sz="1050">
+              <a:endParaRPr sz="1350">
                 <a:solidFill>
                   <a:srgbClr val="CBD5E1"/>
                 </a:solidFill>
@@ -16119,7 +16211,7 @@
                 <a:buNone/>
               </a:pPr>
               <a:r>
-                <a:rPr b="1" lang="en-US" sz="1200">
+                <a:rPr b="1" lang="en-US" sz="1500">
                   <a:solidFill>
                     <a:srgbClr val="00D2FF"/>
                   </a:solidFill>
@@ -16130,7 +16222,7 @@
                 </a:rPr>
                 <a:t>Benchmark NER</a:t>
               </a:r>
-              <a:endParaRPr b="1" sz="1200">
+              <a:endParaRPr b="1" sz="1500">
                 <a:solidFill>
                   <a:srgbClr val="00D2FF"/>
                 </a:solidFill>
@@ -16151,7 +16243,7 @@
                 <a:buNone/>
               </a:pPr>
               <a:r>
-                <a:rPr lang="en-US" sz="1050">
+                <a:rPr lang="en-US" sz="1350">
                   <a:solidFill>
                     <a:srgbClr val="CBD5E1"/>
                   </a:solidFill>
@@ -16162,7 +16254,7 @@
                 </a:rPr>
                 <a:t>BioBERT + Qwen vs. TF-IDF + segmentation + SBERT</a:t>
               </a:r>
-              <a:endParaRPr sz="1050">
+              <a:endParaRPr sz="1350">
                 <a:solidFill>
                   <a:srgbClr val="CBD5E1"/>
                 </a:solidFill>
@@ -17520,7 +17612,7 @@
             <a:tbl>
               <a:tblPr bandRow="1" firstRow="1">
                 <a:noFill/>
-                <a:tableStyleId>{5C874406-496D-439C-BDEF-28BF0047C382}</a:tableStyleId>
+                <a:tableStyleId>{5D8E7B14-1A53-479F-AF55-B245E0A7D556}</a:tableStyleId>
               </a:tblPr>
               <a:tblGrid>
                 <a:gridCol w="3291850"/>
@@ -18229,8 +18321,8 @@
         </p:nvSpPr>
         <p:spPr>
           <a:xfrm>
-            <a:off x="731525" y="3749047"/>
-            <a:ext cx="3383400" cy="1470600"/>
+            <a:off x="731525" y="3749049"/>
+            <a:ext cx="3383400" cy="881700"/>
           </a:xfrm>
           <a:prstGeom prst="roundRect">
             <a:avLst>
@@ -18299,7 +18391,7 @@
         <p:spPr>
           <a:xfrm>
             <a:off x="868675" y="3840476"/>
-            <a:ext cx="3108900" cy="1159500"/>
+            <a:ext cx="3108900" cy="523200"/>
           </a:xfrm>
           <a:prstGeom prst="rect">
             <a:avLst/>
@@ -18368,33 +18460,6 @@
             </a:r>
             <a:endParaRPr/>
           </a:p>
-          <a:p>
-            <a:pPr indent="0" lvl="0" marL="0" marR="0" rtl="0" algn="l">
-              <a:lnSpc>
-                <a:spcPct val="100000"/>
-              </a:lnSpc>
-              <a:spcBef>
-                <a:spcPts val="400"/>
-              </a:spcBef>
-              <a:spcAft>
-                <a:spcPts val="0"/>
-              </a:spcAft>
-              <a:buNone/>
-            </a:pPr>
-            <a:r>
-              <a:rPr b="0" i="0" lang="en-US" sz="950" u="none" cap="none" strike="noStrike">
-                <a:solidFill>
-                  <a:srgbClr val="94A3B8"/>
-                </a:solidFill>
-                <a:latin typeface="Arial"/>
-                <a:ea typeface="Arial"/>
-                <a:cs typeface="Arial"/>
-                <a:sym typeface="Arial"/>
-              </a:rPr>
-              <a:t>Élimination des fausses détections : sur 100 entités extraites par le modèle LoRA, 63 sont strictement conformes au consensus médical (vs 44 pour Qwen brut).</a:t>
-            </a:r>
-            <a:endParaRPr/>
-          </a:p>
         </p:txBody>
       </p:sp>
       <p:sp>
@@ -18405,8 +18470,8 @@
         </p:nvSpPr>
         <p:spPr>
           <a:xfrm>
-            <a:off x="4389125" y="3749047"/>
-            <a:ext cx="3383400" cy="1470600"/>
+            <a:off x="4389125" y="3749050"/>
+            <a:ext cx="3383400" cy="881700"/>
           </a:xfrm>
           <a:prstGeom prst="roundRect">
             <a:avLst>
@@ -18475,7 +18540,7 @@
         <p:spPr>
           <a:xfrm>
             <a:off x="4526275" y="3840476"/>
-            <a:ext cx="3108900" cy="1013400"/>
+            <a:ext cx="3108900" cy="790200"/>
           </a:xfrm>
           <a:prstGeom prst="rect">
             <a:avLst/>
@@ -18558,16 +18623,7 @@
               <a:buNone/>
             </a:pPr>
             <a:r>
-              <a:rPr b="0" i="0" lang="en-US" sz="950" u="none" cap="none" strike="noStrike">
-                <a:solidFill>
-                  <a:srgbClr val="94A3B8"/>
-                </a:solidFill>
-                <a:latin typeface="Arial"/>
-                <a:ea typeface="Arial"/>
-                <a:cs typeface="Arial"/>
-                <a:sym typeface="Arial"/>
-              </a:rPr>
-              <a:t>Moteur d'inférence haute performance vLLM (PagedAttention) : temps moyen d'inférence &lt; 0,5s par paragraphe d'éligibilité sur carte L4.</a:t>
+              <a:t/>
             </a:r>
             <a:endParaRPr/>
           </a:p>
@@ -18581,8 +18637,8 @@
         </p:nvSpPr>
         <p:spPr>
           <a:xfrm>
-            <a:off x="8046725" y="3749047"/>
-            <a:ext cx="3383400" cy="1470600"/>
+            <a:off x="8046725" y="3749049"/>
+            <a:ext cx="3383400" cy="881700"/>
           </a:xfrm>
           <a:prstGeom prst="roundRect">
             <a:avLst>
@@ -18651,7 +18707,7 @@
         <p:spPr>
           <a:xfrm>
             <a:off x="8183875" y="3840476"/>
-            <a:ext cx="3108900" cy="1013400"/>
+            <a:ext cx="3108900" cy="790200"/>
           </a:xfrm>
           <a:prstGeom prst="rect">
             <a:avLst/>
@@ -18734,16 +18790,7 @@
               <a:buNone/>
             </a:pPr>
             <a:r>
-              <a:rPr b="0" i="0" lang="en-US" sz="950" u="none" cap="none" strike="noStrike">
-                <a:solidFill>
-                  <a:srgbClr val="94A3B8"/>
-                </a:solidFill>
-                <a:latin typeface="Arial"/>
-                <a:ea typeface="Arial"/>
-                <a:cs typeface="Arial"/>
-                <a:sym typeface="Arial"/>
-              </a:rPr>
-              <a:t>Poids LoRA ultra-légers (40 Mo au lieu de 14 Go) greffés à chaud sur le cerveau de base. Coût d'entraînement et de stockage divisé par plus de 50.</a:t>
+              <a:t/>
             </a:r>
             <a:endParaRPr/>
           </a:p>
@@ -18757,7 +18804,7 @@
         </p:nvSpPr>
         <p:spPr>
           <a:xfrm>
-            <a:off x="653875" y="5585400"/>
+            <a:off x="779900" y="5087850"/>
             <a:ext cx="11010000" cy="598500"/>
           </a:xfrm>
           <a:prstGeom prst="rect">
@@ -20096,7 +20143,7 @@
         <p:spPr>
           <a:xfrm>
             <a:off x="1783300" y="3990150"/>
-            <a:ext cx="8675700" cy="1616100"/>
+            <a:ext cx="8675700" cy="831300"/>
           </a:xfrm>
           <a:prstGeom prst="rect">
             <a:avLst/>
@@ -20169,43 +20216,7 @@
               <a:buNone/>
             </a:pPr>
             <a:r>
-              <a:rPr b="1" i="0" lang="en-US" sz="1800" u="none" cap="none" strike="noStrike">
-                <a:solidFill>
-                  <a:srgbClr val="FFFFFF"/>
-                </a:solidFill>
-                <a:latin typeface="Montserrat"/>
-                <a:ea typeface="Montserrat"/>
-                <a:cs typeface="Montserrat"/>
-                <a:sym typeface="Montserrat"/>
-              </a:rPr>
-              <a:t>Candidat : Christopher Gilleron</a:t>
-            </a:r>
-            <a:endParaRPr/>
-          </a:p>
-          <a:p>
-            <a:pPr indent="0" lvl="0" marL="0" marR="0" rtl="0" algn="l">
-              <a:lnSpc>
-                <a:spcPct val="100000"/>
-              </a:lnSpc>
-              <a:spcBef>
-                <a:spcPts val="0"/>
-              </a:spcBef>
-              <a:spcAft>
-                <a:spcPts val="0"/>
-              </a:spcAft>
-              <a:buNone/>
-            </a:pPr>
-            <a:r>
-              <a:rPr b="0" i="0" lang="en-US" sz="1300" u="none" cap="none" strike="noStrike">
-                <a:solidFill>
-                  <a:srgbClr val="94A3B8"/>
-                </a:solidFill>
-                <a:latin typeface="Montserrat"/>
-                <a:ea typeface="Montserrat"/>
-                <a:cs typeface="Montserrat"/>
-                <a:sym typeface="Montserrat"/>
-              </a:rPr>
-              <a:t>Certification Concepteur Développeur en Science des Données (CDSD)</a:t>
+              <a:t/>
             </a:r>
             <a:endParaRPr/>
           </a:p>

</xml_diff>

<commit_message>
fix(tinder): harmonisation rigoureuse des metriques notebook et generation chart slide 3 corrige
</commit_message>
<xml_diff>
--- a/Bloc_6_CliNER/CliNER_presentation.pptx
+++ b/Bloc_6_CliNER/CliNER_presentation.pptx
@@ -289,7 +289,7 @@
       </p15:sldGuideLst>
     </p:ext>
     <p:ext uri="GoogleSlidesCustomDataVersion2">
-      <go:slidesCustomData xmlns:go="http://customooxmlschemas.google.com/" r:id="rId26" roundtripDataSignature="AMtx7mi9qXIv1QJ2f1NCYKviN50K6o8NkA=="/>
+      <go:slidesCustomData xmlns:go="http://customooxmlschemas.google.com/" r:id="rId26" roundtripDataSignature="AMtx7mi8lPam4rv4jR/1xV2F/NRwWlVw3w=="/>
     </p:ext>
   </p:extLst>
 </p:presentation>
@@ -15504,7 +15504,7 @@
               <a:buNone/>
             </a:pPr>
             <a:r>
-              <a:rPr b="0" lang="en-US" sz="2800">
+              <a:rPr b="0" lang="en-US" sz="2900">
                 <a:solidFill>
                   <a:srgbClr val="00D2FF"/>
                 </a:solidFill>
@@ -15515,7 +15515,7 @@
               </a:rPr>
               <a:t>1. Le Problème &amp; Le MVP</a:t>
             </a:r>
-            <a:endParaRPr b="0" sz="2800">
+            <a:endParaRPr b="0" sz="2900">
               <a:solidFill>
                 <a:srgbClr val="00D2FF"/>
               </a:solidFill>
@@ -15535,10 +15535,10 @@
         </p:nvGrpSpPr>
         <p:grpSpPr>
           <a:xfrm>
-            <a:off x="762000" y="1047750"/>
-            <a:ext cx="5143500" cy="5381700"/>
+            <a:off x="762000" y="1000125"/>
+            <a:ext cx="3352800" cy="5429400"/>
             <a:chOff x="0" y="0"/>
-            <a:chExt cx="5143500" cy="5381700"/>
+            <a:chExt cx="3352800" cy="5429400"/>
           </a:xfrm>
         </p:grpSpPr>
         <p:sp>
@@ -15550,15 +15550,17 @@
           <p:spPr>
             <a:xfrm>
               <a:off x="0" y="0"/>
-              <a:ext cx="5143500" cy="5381700"/>
+              <a:ext cx="3352800" cy="5429400"/>
             </a:xfrm>
             <a:prstGeom prst="roundRect">
               <a:avLst>
-                <a:gd fmla="val 2962" name="adj"/>
+                <a:gd fmla="val 3977" name="adj"/>
               </a:avLst>
             </a:prstGeom>
             <a:solidFill>
-              <a:srgbClr val="00152F"/>
+              <a:srgbClr val="00152F">
+                <a:alpha val="95000"/>
+              </a:srgbClr>
             </a:solidFill>
             <a:ln cap="flat" cmpd="sng" w="14300">
               <a:solidFill>
@@ -15588,7 +15590,7 @@
               <a:r>
                 <a:t/>
               </a:r>
-              <a:endParaRPr/>
+              <a:endParaRPr sz="1700"/>
             </a:p>
           </p:txBody>
         </p:sp>
@@ -15600,8 +15602,8 @@
           </p:nvSpPr>
           <p:spPr>
             <a:xfrm>
-              <a:off x="238125" y="238125"/>
-              <a:ext cx="4667400" cy="4905300"/>
+              <a:off x="0" y="0"/>
+              <a:ext cx="3352800" cy="5429400"/>
             </a:xfrm>
             <a:prstGeom prst="rect">
               <a:avLst/>
@@ -15612,7 +15614,7 @@
             </a:ln>
           </p:spPr>
           <p:txBody>
-            <a:bodyPr anchorCtr="0" anchor="t" bIns="0" lIns="0" spcFirstLastPara="1" rIns="0" wrap="square" tIns="0">
+            <a:bodyPr anchorCtr="0" anchor="ctr" bIns="209550" lIns="209550" spcFirstLastPara="1" rIns="209550" wrap="square" tIns="209550">
               <a:noAutofit/>
             </a:bodyPr>
             <a:lstStyle/>
@@ -15627,7 +15629,7 @@
                 <a:buNone/>
               </a:pPr>
               <a:r>
-                <a:rPr b="1" lang="en-US" sz="2300">
+                <a:rPr b="1" lang="en-US" sz="2100">
                   <a:solidFill>
                     <a:srgbClr val="FF6B6B"/>
                   </a:solidFill>
@@ -15638,7 +15640,7 @@
                 </a:rPr>
                 <a:t>⚠️ Le Chaos Médical</a:t>
               </a:r>
-              <a:endParaRPr b="1" sz="2300">
+              <a:endParaRPr b="1" sz="2100">
                 <a:solidFill>
                   <a:srgbClr val="FF6B6B"/>
                 </a:solidFill>
@@ -15651,7 +15653,7 @@
             <a:p>
               <a:pPr indent="0" lvl="0" marL="0" rtl="0" algn="l">
                 <a:spcBef>
-                  <a:spcPts val="1200"/>
+                  <a:spcPts val="0"/>
                 </a:spcBef>
                 <a:spcAft>
                   <a:spcPts val="0"/>
@@ -15659,7 +15661,30 @@
                 <a:buNone/>
               </a:pPr>
               <a:r>
-                <a:rPr b="1" lang="en-US" sz="1500">
+                <a:t/>
+              </a:r>
+              <a:endParaRPr b="1" sz="2100">
+                <a:solidFill>
+                  <a:srgbClr val="FF6B6B"/>
+                </a:solidFill>
+                <a:latin typeface="Montserrat"/>
+                <a:ea typeface="Montserrat"/>
+                <a:cs typeface="Montserrat"/>
+                <a:sym typeface="Montserrat"/>
+              </a:endParaRPr>
+            </a:p>
+            <a:p>
+              <a:pPr indent="0" lvl="0" marL="0" rtl="0" algn="l">
+                <a:spcBef>
+                  <a:spcPts val="0"/>
+                </a:spcBef>
+                <a:spcAft>
+                  <a:spcPts val="0"/>
+                </a:spcAft>
+                <a:buNone/>
+              </a:pPr>
+              <a:r>
+                <a:rPr b="1" lang="en-US">
                   <a:solidFill>
                     <a:srgbClr val="FF6B6B"/>
                   </a:solidFill>
@@ -15671,7 +15696,7 @@
                 <a:t>Objectif :</a:t>
               </a:r>
               <a:r>
-                <a:rPr lang="en-US" sz="1500">
+                <a:rPr b="0" lang="en-US">
                   <a:solidFill>
                     <a:srgbClr val="F1F5F9"/>
                   </a:solidFill>
@@ -15682,7 +15707,7 @@
                 </a:rPr>
                 <a:t> Comparer efficacement des essais cliniques</a:t>
               </a:r>
-              <a:endParaRPr sz="1500">
+              <a:endParaRPr b="0">
                 <a:solidFill>
                   <a:srgbClr val="F1F5F9"/>
                 </a:solidFill>
@@ -15695,7 +15720,7 @@
             <a:p>
               <a:pPr indent="0" lvl="0" marL="0" rtl="0" algn="l">
                 <a:spcBef>
-                  <a:spcPts val="1650"/>
+                  <a:spcPts val="0"/>
                 </a:spcBef>
                 <a:spcAft>
                   <a:spcPts val="0"/>
@@ -15712,7 +15737,7 @@
                   <a:cs typeface="Montserrat"/>
                   <a:sym typeface="Montserrat"/>
                 </a:rPr>
-                <a:t>Données officielles hétérogènes</a:t>
+                <a:t>Données hétérogènes</a:t>
               </a:r>
               <a:endParaRPr b="1" sz="1600">
                 <a:solidFill>
@@ -15727,7 +15752,7 @@
             <a:p>
               <a:pPr indent="0" lvl="0" marL="0" rtl="0" algn="l">
                 <a:spcBef>
-                  <a:spcPts val="300"/>
+                  <a:spcPts val="225"/>
                 </a:spcBef>
                 <a:spcAft>
                   <a:spcPts val="0"/>
@@ -15735,7 +15760,7 @@
                 <a:buNone/>
               </a:pPr>
               <a:r>
-                <a:rPr lang="en-US">
+                <a:rPr b="0" lang="en-US">
                   <a:solidFill>
                     <a:srgbClr val="CBD5E1"/>
                   </a:solidFill>
@@ -15746,7 +15771,7 @@
                 </a:rPr>
                 <a:t>ClinicalTrials fournit des JSON incomplets et non structurés.</a:t>
               </a:r>
-              <a:endParaRPr>
+              <a:endParaRPr b="0">
                 <a:solidFill>
                   <a:srgbClr val="CBD5E1"/>
                 </a:solidFill>
@@ -15759,7 +15784,7 @@
             <a:p>
               <a:pPr indent="0" lvl="0" marL="0" rtl="0" algn="l">
                 <a:spcBef>
-                  <a:spcPts val="1350"/>
+                  <a:spcPts val="0"/>
                 </a:spcBef>
                 <a:spcAft>
                   <a:spcPts val="0"/>
@@ -15791,7 +15816,7 @@
             <a:p>
               <a:pPr indent="0" lvl="0" marL="0" rtl="0" algn="l">
                 <a:spcBef>
-                  <a:spcPts val="300"/>
+                  <a:spcPts val="225"/>
                 </a:spcBef>
                 <a:spcAft>
                   <a:spcPts val="0"/>
@@ -15799,7 +15824,7 @@
                 <a:buNone/>
               </a:pPr>
               <a:r>
-                <a:rPr lang="en-US">
+                <a:rPr b="0" lang="en-US">
                   <a:solidFill>
                     <a:srgbClr val="CBD5E1"/>
                   </a:solidFill>
@@ -15810,7 +15835,7 @@
                 </a:rPr>
                 <a:t>L'information cruciale est enfouie dans des documents PDF de 100 à 200 pages.</a:t>
               </a:r>
-              <a:endParaRPr>
+              <a:endParaRPr b="0">
                 <a:solidFill>
                   <a:srgbClr val="CBD5E1"/>
                 </a:solidFill>
@@ -15823,7 +15848,7 @@
             <a:p>
               <a:pPr indent="0" lvl="0" marL="0" rtl="0" algn="l">
                 <a:spcBef>
-                  <a:spcPts val="1350"/>
+                  <a:spcPts val="0"/>
                 </a:spcBef>
                 <a:spcAft>
                   <a:spcPts val="0"/>
@@ -15855,7 +15880,7 @@
             <a:p>
               <a:pPr indent="0" lvl="0" marL="0" rtl="0" algn="l">
                 <a:spcBef>
-                  <a:spcPts val="300"/>
+                  <a:spcPts val="225"/>
                 </a:spcBef>
                 <a:spcAft>
                   <a:spcPts val="0"/>
@@ -15863,7 +15888,7 @@
                 <a:buNone/>
               </a:pPr>
               <a:r>
-                <a:rPr lang="en-US">
+                <a:rPr b="0" lang="en-US">
                   <a:solidFill>
                     <a:srgbClr val="CBD5E1"/>
                   </a:solidFill>
@@ -15874,7 +15899,7 @@
                 </a:rPr>
                 <a:t>Impossible de vérifier si 2 essais sur un même médicament partagent des conditions comparables.</a:t>
               </a:r>
-              <a:endParaRPr>
+              <a:endParaRPr b="0">
                 <a:solidFill>
                   <a:srgbClr val="CBD5E1"/>
                 </a:solidFill>
@@ -15895,10 +15920,10 @@
         </p:nvGrpSpPr>
         <p:grpSpPr>
           <a:xfrm>
-            <a:off x="6286500" y="1047750"/>
-            <a:ext cx="5143500" cy="5381700"/>
+            <a:off x="4419600" y="1000125"/>
+            <a:ext cx="3352800" cy="5429400"/>
             <a:chOff x="0" y="0"/>
-            <a:chExt cx="5143500" cy="5381700"/>
+            <a:chExt cx="3352800" cy="5429400"/>
           </a:xfrm>
         </p:grpSpPr>
         <p:sp>
@@ -15910,15 +15935,17 @@
           <p:spPr>
             <a:xfrm>
               <a:off x="0" y="0"/>
-              <a:ext cx="5143500" cy="5381700"/>
+              <a:ext cx="3352800" cy="5429400"/>
             </a:xfrm>
             <a:prstGeom prst="roundRect">
               <a:avLst>
-                <a:gd fmla="val 2962" name="adj"/>
+                <a:gd fmla="val 3977" name="adj"/>
               </a:avLst>
             </a:prstGeom>
             <a:solidFill>
-              <a:srgbClr val="00152F"/>
+              <a:srgbClr val="00152F">
+                <a:alpha val="95000"/>
+              </a:srgbClr>
             </a:solidFill>
             <a:ln cap="flat" cmpd="sng" w="14300">
               <a:solidFill>
@@ -15948,7 +15975,7 @@
               <a:r>
                 <a:t/>
               </a:r>
-              <a:endParaRPr/>
+              <a:endParaRPr sz="1700"/>
             </a:p>
           </p:txBody>
         </p:sp>
@@ -15960,8 +15987,8 @@
           </p:nvSpPr>
           <p:spPr>
             <a:xfrm>
-              <a:off x="238125" y="238125"/>
-              <a:ext cx="4667400" cy="3524400"/>
+              <a:off x="0" y="0"/>
+              <a:ext cx="3352800" cy="5429400"/>
             </a:xfrm>
             <a:prstGeom prst="rect">
               <a:avLst/>
@@ -15972,7 +15999,7 @@
             </a:ln>
           </p:spPr>
           <p:txBody>
-            <a:bodyPr anchorCtr="0" anchor="t" bIns="0" lIns="0" spcFirstLastPara="1" rIns="0" wrap="square" tIns="0">
+            <a:bodyPr anchorCtr="0" anchor="ctr" bIns="209550" lIns="209550" spcFirstLastPara="1" rIns="209550" wrap="square" tIns="209550">
               <a:noAutofit/>
             </a:bodyPr>
             <a:lstStyle/>
@@ -15987,7 +16014,7 @@
                 <a:buNone/>
               </a:pPr>
               <a:r>
-                <a:rPr b="1" lang="en-US" sz="2300">
+                <a:rPr b="1" lang="en-US" sz="2100">
                   <a:solidFill>
                     <a:srgbClr val="00D2FF"/>
                   </a:solidFill>
@@ -15998,7 +16025,7 @@
                 </a:rPr>
                 <a:t>🚀 La Solution (MVP)</a:t>
               </a:r>
-              <a:endParaRPr b="1" sz="2300">
+              <a:endParaRPr b="1" sz="2100">
                 <a:solidFill>
                   <a:srgbClr val="00D2FF"/>
                 </a:solidFill>
@@ -16011,7 +16038,7 @@
             <a:p>
               <a:pPr indent="0" lvl="0" marL="0" rtl="0" algn="l">
                 <a:spcBef>
-                  <a:spcPts val="1200"/>
+                  <a:spcPts val="0"/>
                 </a:spcBef>
                 <a:spcAft>
                   <a:spcPts val="0"/>
@@ -16019,7 +16046,7 @@
                 <a:buNone/>
               </a:pPr>
               <a:r>
-                <a:rPr b="1" lang="en-US" sz="1500">
+                <a:rPr b="1" lang="en-US" sz="1600">
                   <a:solidFill>
                     <a:srgbClr val="00D2FF"/>
                   </a:solidFill>
@@ -16030,7 +16057,7 @@
                 </a:rPr>
                 <a:t>NER (Qwen Fine-Tuné)</a:t>
               </a:r>
-              <a:endParaRPr b="1" sz="1500">
+              <a:endParaRPr b="1" sz="1600">
                 <a:solidFill>
                   <a:srgbClr val="00D2FF"/>
                 </a:solidFill>
@@ -16043,7 +16070,7 @@
             <a:p>
               <a:pPr indent="0" lvl="0" marL="0" rtl="0" algn="l">
                 <a:spcBef>
-                  <a:spcPts val="150"/>
+                  <a:spcPts val="0"/>
                 </a:spcBef>
                 <a:spcAft>
                   <a:spcPts val="0"/>
@@ -16051,20 +16078,11 @@
                 <a:buNone/>
               </a:pPr>
               <a:r>
-                <a:rPr lang="en-US" sz="1350">
-                  <a:solidFill>
-                    <a:srgbClr val="F1F5F9"/>
-                  </a:solidFill>
-                  <a:latin typeface="Montserrat"/>
-                  <a:ea typeface="Montserrat"/>
-                  <a:cs typeface="Montserrat"/>
-                  <a:sym typeface="Montserrat"/>
-                </a:rPr>
-                <a:t>Extraction d'informations médicales standardisées &amp; filtres</a:t>
+                <a:t/>
               </a:r>
-              <a:endParaRPr sz="1350">
-                <a:solidFill>
-                  <a:srgbClr val="F1F5F9"/>
+              <a:endParaRPr b="1" sz="1600">
+                <a:solidFill>
+                  <a:srgbClr val="00D2FF"/>
                 </a:solidFill>
                 <a:latin typeface="Montserrat"/>
                 <a:ea typeface="Montserrat"/>
@@ -16075,7 +16093,7 @@
             <a:p>
               <a:pPr indent="0" lvl="0" marL="0" rtl="0" algn="l">
                 <a:spcBef>
-                  <a:spcPts val="900"/>
+                  <a:spcPts val="225"/>
                 </a:spcBef>
                 <a:spcAft>
                   <a:spcPts val="0"/>
@@ -16083,20 +16101,20 @@
                 <a:buNone/>
               </a:pPr>
               <a:r>
-                <a:rPr b="1" lang="en-US" sz="1500">
+                <a:rPr b="0" lang="en-US">
                   <a:solidFill>
-                    <a:srgbClr val="00D2FF"/>
+                    <a:srgbClr val="F1F5F9"/>
                   </a:solidFill>
                   <a:latin typeface="Montserrat"/>
                   <a:ea typeface="Montserrat"/>
                   <a:cs typeface="Montserrat"/>
                   <a:sym typeface="Montserrat"/>
                 </a:rPr>
-                <a:t>Recherche Augmentée (RAG BioBERT)</a:t>
+                <a:t>Extraction d'informations médicales standardisées &amp; filtres.</a:t>
               </a:r>
-              <a:endParaRPr b="1" sz="1500">
-                <a:solidFill>
-                  <a:srgbClr val="00D2FF"/>
+              <a:endParaRPr b="0">
+                <a:solidFill>
+                  <a:srgbClr val="F1F5F9"/>
                 </a:solidFill>
                 <a:latin typeface="Montserrat"/>
                 <a:ea typeface="Montserrat"/>
@@ -16107,7 +16125,7 @@
             <a:p>
               <a:pPr indent="0" lvl="0" marL="0" rtl="0" algn="l">
                 <a:spcBef>
-                  <a:spcPts val="150"/>
+                  <a:spcPts val="0"/>
                 </a:spcBef>
                 <a:spcAft>
                   <a:spcPts val="0"/>
@@ -16115,20 +16133,20 @@
                 <a:buNone/>
               </a:pPr>
               <a:r>
-                <a:rPr lang="en-US" sz="1350">
+                <a:rPr b="1" lang="en-US" sz="1600">
                   <a:solidFill>
-                    <a:srgbClr val="F1F5F9"/>
+                    <a:srgbClr val="00D2FF"/>
                   </a:solidFill>
                   <a:latin typeface="Montserrat"/>
                   <a:ea typeface="Montserrat"/>
                   <a:cs typeface="Montserrat"/>
                   <a:sym typeface="Montserrat"/>
                 </a:rPr>
-                <a:t>Interrogation instantanée des protocoles cliniques en langage naturel</a:t>
+                <a:t>Recherche Augmentée (RAG)</a:t>
               </a:r>
-              <a:endParaRPr sz="1350">
-                <a:solidFill>
-                  <a:srgbClr val="F1F5F9"/>
+              <a:endParaRPr b="1" sz="1600">
+                <a:solidFill>
+                  <a:srgbClr val="00D2FF"/>
                 </a:solidFill>
                 <a:latin typeface="Montserrat"/>
                 <a:ea typeface="Montserrat"/>
@@ -16139,7 +16157,7 @@
             <a:p>
               <a:pPr indent="0" lvl="0" marL="0" rtl="0" algn="l">
                 <a:spcBef>
-                  <a:spcPts val="900"/>
+                  <a:spcPts val="225"/>
                 </a:spcBef>
                 <a:spcAft>
                   <a:spcPts val="0"/>
@@ -16147,20 +16165,20 @@
                 <a:buNone/>
               </a:pPr>
               <a:r>
-                <a:rPr b="1" lang="en-US" sz="1500">
+                <a:rPr b="0" lang="en-US">
                   <a:solidFill>
-                    <a:srgbClr val="00D2FF"/>
+                    <a:srgbClr val="F1F5F9"/>
                   </a:solidFill>
                   <a:latin typeface="Montserrat"/>
                   <a:ea typeface="Montserrat"/>
                   <a:cs typeface="Montserrat"/>
                   <a:sym typeface="Montserrat"/>
                 </a:rPr>
-                <a:t>Gold Standard (Chia Dataset)</a:t>
+                <a:t>Interrogation instantanée des protocoles BioBERT en langage naturel.</a:t>
               </a:r>
-              <a:endParaRPr b="1" sz="1500">
-                <a:solidFill>
-                  <a:srgbClr val="00D2FF"/>
+              <a:endParaRPr b="0">
+                <a:solidFill>
+                  <a:srgbClr val="F1F5F9"/>
                 </a:solidFill>
                 <a:latin typeface="Montserrat"/>
                 <a:ea typeface="Montserrat"/>
@@ -16171,7 +16189,7 @@
             <a:p>
               <a:pPr indent="0" lvl="0" marL="0" rtl="0" algn="l">
                 <a:spcBef>
-                  <a:spcPts val="150"/>
+                  <a:spcPts val="0"/>
                 </a:spcBef>
                 <a:spcAft>
                   <a:spcPts val="0"/>
@@ -16179,20 +16197,20 @@
                 <a:buNone/>
               </a:pPr>
               <a:r>
-                <a:rPr lang="en-US" sz="1350">
+                <a:rPr b="1" lang="en-US" sz="1600">
                   <a:solidFill>
-                    <a:srgbClr val="CBD5E1"/>
+                    <a:srgbClr val="00D2FF"/>
                   </a:solidFill>
                   <a:latin typeface="Montserrat"/>
                   <a:ea typeface="Montserrat"/>
                   <a:cs typeface="Montserrat"/>
                   <a:sym typeface="Montserrat"/>
                 </a:rPr>
-                <a:t>1 000 études annotées (144 avec PDF), réparties en Train &amp; Test sets</a:t>
+                <a:t>Gold Standard (Chia)</a:t>
               </a:r>
-              <a:endParaRPr sz="1350">
-                <a:solidFill>
-                  <a:srgbClr val="CBD5E1"/>
+              <a:endParaRPr b="1" sz="1600">
+                <a:solidFill>
+                  <a:srgbClr val="00D2FF"/>
                 </a:solidFill>
                 <a:latin typeface="Montserrat"/>
                 <a:ea typeface="Montserrat"/>
@@ -16203,7 +16221,7 @@
             <a:p>
               <a:pPr indent="0" lvl="0" marL="0" rtl="0" algn="l">
                 <a:spcBef>
-                  <a:spcPts val="900"/>
+                  <a:spcPts val="225"/>
                 </a:spcBef>
                 <a:spcAft>
                   <a:spcPts val="0"/>
@@ -16211,7 +16229,39 @@
                 <a:buNone/>
               </a:pPr>
               <a:r>
-                <a:rPr b="1" lang="en-US" sz="1500">
+                <a:rPr b="0" lang="en-US">
+                  <a:solidFill>
+                    <a:srgbClr val="CBD5E1"/>
+                  </a:solidFill>
+                  <a:latin typeface="Montserrat"/>
+                  <a:ea typeface="Montserrat"/>
+                  <a:cs typeface="Montserrat"/>
+                  <a:sym typeface="Montserrat"/>
+                </a:rPr>
+                <a:t>1 000 études annotées (144 avec PDF), réparties en Train &amp; Test sets.</a:t>
+              </a:r>
+              <a:endParaRPr b="0">
+                <a:solidFill>
+                  <a:srgbClr val="CBD5E1"/>
+                </a:solidFill>
+                <a:latin typeface="Montserrat"/>
+                <a:ea typeface="Montserrat"/>
+                <a:cs typeface="Montserrat"/>
+                <a:sym typeface="Montserrat"/>
+              </a:endParaRPr>
+            </a:p>
+            <a:p>
+              <a:pPr indent="0" lvl="0" marL="0" rtl="0" algn="l">
+                <a:spcBef>
+                  <a:spcPts val="0"/>
+                </a:spcBef>
+                <a:spcAft>
+                  <a:spcPts val="0"/>
+                </a:spcAft>
+                <a:buNone/>
+              </a:pPr>
+              <a:r>
+                <a:rPr b="1" lang="en-US" sz="1600">
                   <a:solidFill>
                     <a:srgbClr val="00D2FF"/>
                   </a:solidFill>
@@ -16222,7 +16272,7 @@
                 </a:rPr>
                 <a:t>Benchmark NER</a:t>
               </a:r>
-              <a:endParaRPr b="1" sz="1500">
+              <a:endParaRPr b="1" sz="1600">
                 <a:solidFill>
                   <a:srgbClr val="00D2FF"/>
                 </a:solidFill>
@@ -16235,7 +16285,7 @@
             <a:p>
               <a:pPr indent="0" lvl="0" marL="0" rtl="0" algn="l">
                 <a:spcBef>
-                  <a:spcPts val="150"/>
+                  <a:spcPts val="225"/>
                 </a:spcBef>
                 <a:spcAft>
                   <a:spcPts val="0"/>
@@ -16243,7 +16293,7 @@
                 <a:buNone/>
               </a:pPr>
               <a:r>
-                <a:rPr lang="en-US" sz="1350">
+                <a:rPr b="0" lang="en-US">
                   <a:solidFill>
                     <a:srgbClr val="CBD5E1"/>
                   </a:solidFill>
@@ -16252,9 +16302,9 @@
                   <a:cs typeface="Montserrat"/>
                   <a:sym typeface="Montserrat"/>
                 </a:rPr>
-                <a:t>BioBERT + Qwen vs. TF-IDF + segmentation + SBERT</a:t>
+                <a:t>BioBERT + Qwen vs. TF-IDF + segmentation + SBERT.</a:t>
               </a:r>
-              <a:endParaRPr sz="1350">
+              <a:endParaRPr b="0">
                 <a:solidFill>
                   <a:srgbClr val="CBD5E1"/>
                 </a:solidFill>
@@ -16266,101 +16316,493 @@
             </a:p>
           </p:txBody>
         </p:sp>
-        <p:grpSp>
-          <p:nvGrpSpPr>
-            <p:cNvPr id="98" name="Google Shape;98;p2"/>
-            <p:cNvGrpSpPr/>
+      </p:grpSp>
+      <p:grpSp>
+        <p:nvGrpSpPr>
+          <p:cNvPr id="98" name="Google Shape;98;p2"/>
+          <p:cNvGrpSpPr/>
+          <p:nvPr/>
+        </p:nvGrpSpPr>
+        <p:grpSpPr>
+          <a:xfrm>
+            <a:off x="8077200" y="1000125"/>
+            <a:ext cx="3352800" cy="5429400"/>
+            <a:chOff x="0" y="0"/>
+            <a:chExt cx="3352800" cy="5429400"/>
+          </a:xfrm>
+        </p:grpSpPr>
+        <p:sp>
+          <p:nvSpPr>
+            <p:cNvPr id="99" name="Google Shape;99;p2"/>
+            <p:cNvSpPr/>
             <p:nvPr/>
-          </p:nvGrpSpPr>
-          <p:grpSpPr>
+          </p:nvSpPr>
+          <p:spPr>
             <a:xfrm>
-              <a:off x="238125" y="3952875"/>
-              <a:ext cx="4667400" cy="1190700"/>
-              <a:chOff x="0" y="0"/>
-              <a:chExt cx="4667400" cy="1190700"/>
+              <a:off x="0" y="0"/>
+              <a:ext cx="3352800" cy="5429400"/>
             </a:xfrm>
-          </p:grpSpPr>
-          <p:sp>
-            <p:nvSpPr>
-              <p:cNvPr id="99" name="Google Shape;99;p2"/>
-              <p:cNvSpPr/>
-              <p:nvPr/>
-            </p:nvSpPr>
-            <p:spPr>
-              <a:xfrm>
-                <a:off x="0" y="0"/>
-                <a:ext cx="4667400" cy="1190700"/>
-              </a:xfrm>
-              <a:prstGeom prst="roundRect">
-                <a:avLst>
-                  <a:gd fmla="val 8000" name="adj"/>
-                </a:avLst>
-              </a:prstGeom>
+            <a:prstGeom prst="roundRect">
+              <a:avLst>
+                <a:gd fmla="val 3977" name="adj"/>
+              </a:avLst>
+            </a:prstGeom>
+            <a:solidFill>
+              <a:srgbClr val="00152F">
+                <a:alpha val="95000"/>
+              </a:srgbClr>
+            </a:solidFill>
+            <a:ln cap="flat" cmpd="sng" w="14300">
               <a:solidFill>
-                <a:srgbClr val="FFFFFF"/>
+                <a:srgbClr val="38BDF8"/>
               </a:solidFill>
-              <a:ln cap="flat" cmpd="sng" w="9525">
-                <a:solidFill>
-                  <a:srgbClr val="00D2FF"/>
-                </a:solidFill>
-                <a:prstDash val="solid"/>
-                <a:round/>
-                <a:headEnd len="sm" w="sm" type="none"/>
-                <a:tailEnd len="sm" w="sm" type="none"/>
-              </a:ln>
-            </p:spPr>
-            <p:txBody>
-              <a:bodyPr anchorCtr="0" anchor="ctr" bIns="0" lIns="0" spcFirstLastPara="1" rIns="0" wrap="square" tIns="0">
-                <a:noAutofit/>
-              </a:bodyPr>
-              <a:lstStyle/>
-              <a:p>
-                <a:pPr indent="0" lvl="0" marL="0" rtl="0" algn="l">
-                  <a:spcBef>
-                    <a:spcPts val="0"/>
-                  </a:spcBef>
-                  <a:spcAft>
-                    <a:spcPts val="0"/>
-                  </a:spcAft>
-                  <a:buNone/>
-                </a:pPr>
-                <a:r>
-                  <a:t/>
-                </a:r>
-                <a:endParaRPr/>
-              </a:p>
-            </p:txBody>
-          </p:sp>
-          <p:pic>
-            <p:nvPicPr>
-              <p:cNvPr id="100" name="Google Shape;100;p2"/>
-              <p:cNvPicPr preferRelativeResize="0"/>
-              <p:nvPr/>
-            </p:nvPicPr>
-            <p:blipFill rotWithShape="1">
-              <a:blip r:embed="rId3">
-                <a:alphaModFix/>
-              </a:blip>
-              <a:srcRect b="593" l="1958" r="3925" t="583"/>
-              <a:stretch/>
-            </p:blipFill>
-            <p:spPr>
-              <a:xfrm>
-                <a:off x="47625" y="47625"/>
-                <a:ext cx="4572000" cy="1095300"/>
-              </a:xfrm>
-              <a:prstGeom prst="roundRect">
-                <a:avLst>
-                  <a:gd fmla="val 5217" name="adj"/>
-                </a:avLst>
-              </a:prstGeom>
+              <a:prstDash val="solid"/>
+              <a:round/>
+              <a:headEnd len="sm" w="sm" type="none"/>
+              <a:tailEnd len="sm" w="sm" type="none"/>
+            </a:ln>
+          </p:spPr>
+          <p:txBody>
+            <a:bodyPr anchorCtr="0" anchor="ctr" bIns="0" lIns="0" spcFirstLastPara="1" rIns="0" wrap="square" tIns="0">
+              <a:noAutofit/>
+            </a:bodyPr>
+            <a:lstStyle/>
+            <a:p>
+              <a:pPr indent="0" lvl="0" marL="0" rtl="0" algn="l">
+                <a:spcBef>
+                  <a:spcPts val="0"/>
+                </a:spcBef>
+                <a:spcAft>
+                  <a:spcPts val="0"/>
+                </a:spcAft>
+                <a:buNone/>
+              </a:pPr>
+              <a:r>
+                <a:t/>
+              </a:r>
+              <a:endParaRPr sz="1700"/>
+            </a:p>
+          </p:txBody>
+        </p:sp>
+        <p:sp>
+          <p:nvSpPr>
+            <p:cNvPr id="100" name="Google Shape;100;p2"/>
+            <p:cNvSpPr txBox="1"/>
+            <p:nvPr/>
+          </p:nvSpPr>
+          <p:spPr>
+            <a:xfrm>
+              <a:off x="0" y="0"/>
+              <a:ext cx="3352800" cy="5429400"/>
+            </a:xfrm>
+            <a:prstGeom prst="rect">
+              <a:avLst/>
+            </a:prstGeom>
+            <a:noFill/>
+            <a:ln>
               <a:noFill/>
-              <a:ln>
-                <a:noFill/>
-              </a:ln>
-            </p:spPr>
-          </p:pic>
-        </p:grpSp>
+            </a:ln>
+          </p:spPr>
+          <p:txBody>
+            <a:bodyPr anchorCtr="0" anchor="ctr" bIns="209550" lIns="209550" spcFirstLastPara="1" rIns="209550" wrap="square" tIns="209550">
+              <a:noAutofit/>
+            </a:bodyPr>
+            <a:lstStyle/>
+            <a:p>
+              <a:pPr indent="0" lvl="0" marL="0" rtl="0" algn="l">
+                <a:spcBef>
+                  <a:spcPts val="0"/>
+                </a:spcBef>
+                <a:spcAft>
+                  <a:spcPts val="0"/>
+                </a:spcAft>
+                <a:buNone/>
+              </a:pPr>
+              <a:r>
+                <a:rPr b="1" lang="en-US" sz="2100">
+                  <a:solidFill>
+                    <a:srgbClr val="38BDF8"/>
+                  </a:solidFill>
+                  <a:latin typeface="Montserrat"/>
+                  <a:ea typeface="Montserrat"/>
+                  <a:cs typeface="Montserrat"/>
+                  <a:sym typeface="Montserrat"/>
+                </a:rPr>
+                <a:t>💼 Cadrage &amp; Déploiement</a:t>
+              </a:r>
+              <a:endParaRPr b="1" sz="2100">
+                <a:solidFill>
+                  <a:srgbClr val="38BDF8"/>
+                </a:solidFill>
+                <a:latin typeface="Montserrat"/>
+                <a:ea typeface="Montserrat"/>
+                <a:cs typeface="Montserrat"/>
+                <a:sym typeface="Montserrat"/>
+              </a:endParaRPr>
+            </a:p>
+            <a:p>
+              <a:pPr indent="0" lvl="0" marL="0" rtl="0" algn="l">
+                <a:spcBef>
+                  <a:spcPts val="0"/>
+                </a:spcBef>
+                <a:spcAft>
+                  <a:spcPts val="0"/>
+                </a:spcAft>
+                <a:buNone/>
+              </a:pPr>
+              <a:r>
+                <a:rPr b="1" lang="en-US" sz="1600">
+                  <a:solidFill>
+                    <a:srgbClr val="38BDF8"/>
+                  </a:solidFill>
+                  <a:latin typeface="Montserrat"/>
+                  <a:ea typeface="Montserrat"/>
+                  <a:cs typeface="Montserrat"/>
+                  <a:sym typeface="Montserrat"/>
+                </a:rPr>
+                <a:t>RGPD / PHI-Free</a:t>
+              </a:r>
+              <a:endParaRPr b="1" sz="1600">
+                <a:solidFill>
+                  <a:srgbClr val="38BDF8"/>
+                </a:solidFill>
+                <a:latin typeface="Montserrat"/>
+                <a:ea typeface="Montserrat"/>
+                <a:cs typeface="Montserrat"/>
+                <a:sym typeface="Montserrat"/>
+              </a:endParaRPr>
+            </a:p>
+            <a:p>
+              <a:pPr indent="0" lvl="0" marL="0" rtl="0" algn="l">
+                <a:spcBef>
+                  <a:spcPts val="0"/>
+                </a:spcBef>
+                <a:spcAft>
+                  <a:spcPts val="0"/>
+                </a:spcAft>
+                <a:buNone/>
+              </a:pPr>
+              <a:r>
+                <a:t/>
+              </a:r>
+              <a:endParaRPr b="1" sz="1600">
+                <a:solidFill>
+                  <a:srgbClr val="38BDF8"/>
+                </a:solidFill>
+                <a:latin typeface="Montserrat"/>
+                <a:ea typeface="Montserrat"/>
+                <a:cs typeface="Montserrat"/>
+                <a:sym typeface="Montserrat"/>
+              </a:endParaRPr>
+            </a:p>
+            <a:p>
+              <a:pPr indent="0" lvl="0" marL="0" rtl="0" algn="l">
+                <a:spcBef>
+                  <a:spcPts val="225"/>
+                </a:spcBef>
+                <a:spcAft>
+                  <a:spcPts val="0"/>
+                </a:spcAft>
+                <a:buNone/>
+              </a:pPr>
+              <a:r>
+                <a:rPr b="0" lang="en-US">
+                  <a:solidFill>
+                    <a:srgbClr val="CBD5E1"/>
+                  </a:solidFill>
+                  <a:latin typeface="Montserrat"/>
+                  <a:ea typeface="Montserrat"/>
+                  <a:cs typeface="Montserrat"/>
+                  <a:sym typeface="Montserrat"/>
+                </a:rPr>
+                <a:t>Traitement exclusif d'essais publics sans aucune donnée patient (Privacy by Design).</a:t>
+              </a:r>
+              <a:endParaRPr b="0">
+                <a:solidFill>
+                  <a:srgbClr val="CBD5E1"/>
+                </a:solidFill>
+                <a:latin typeface="Montserrat"/>
+                <a:ea typeface="Montserrat"/>
+                <a:cs typeface="Montserrat"/>
+                <a:sym typeface="Montserrat"/>
+              </a:endParaRPr>
+            </a:p>
+            <a:p>
+              <a:pPr indent="0" lvl="0" marL="0" rtl="0" algn="l">
+                <a:spcBef>
+                  <a:spcPts val="0"/>
+                </a:spcBef>
+                <a:spcAft>
+                  <a:spcPts val="0"/>
+                </a:spcAft>
+                <a:buNone/>
+              </a:pPr>
+              <a:r>
+                <a:rPr b="1" lang="en-US" sz="1600">
+                  <a:solidFill>
+                    <a:srgbClr val="38BDF8"/>
+                  </a:solidFill>
+                  <a:latin typeface="Montserrat"/>
+                  <a:ea typeface="Montserrat"/>
+                  <a:cs typeface="Montserrat"/>
+                  <a:sym typeface="Montserrat"/>
+                </a:rPr>
+                <a:t>Souveraineté Hospitalière</a:t>
+              </a:r>
+              <a:endParaRPr b="1" sz="1600">
+                <a:solidFill>
+                  <a:srgbClr val="38BDF8"/>
+                </a:solidFill>
+                <a:latin typeface="Montserrat"/>
+                <a:ea typeface="Montserrat"/>
+                <a:cs typeface="Montserrat"/>
+                <a:sym typeface="Montserrat"/>
+              </a:endParaRPr>
+            </a:p>
+            <a:p>
+              <a:pPr indent="0" lvl="0" marL="0" rtl="0" algn="l">
+                <a:spcBef>
+                  <a:spcPts val="225"/>
+                </a:spcBef>
+                <a:spcAft>
+                  <a:spcPts val="0"/>
+                </a:spcAft>
+                <a:buNone/>
+              </a:pPr>
+              <a:r>
+                <a:rPr b="0" lang="en-US">
+                  <a:solidFill>
+                    <a:srgbClr val="CBD5E1"/>
+                  </a:solidFill>
+                  <a:latin typeface="Montserrat"/>
+                  <a:ea typeface="Montserrat"/>
+                  <a:cs typeface="Montserrat"/>
+                  <a:sym typeface="Montserrat"/>
+                </a:rPr>
+                <a:t>Architecture 100% local (on-premise) sans dépendance vers des API tierces.</a:t>
+              </a:r>
+              <a:endParaRPr b="0">
+                <a:solidFill>
+                  <a:srgbClr val="CBD5E1"/>
+                </a:solidFill>
+                <a:latin typeface="Montserrat"/>
+                <a:ea typeface="Montserrat"/>
+                <a:cs typeface="Montserrat"/>
+                <a:sym typeface="Montserrat"/>
+              </a:endParaRPr>
+            </a:p>
+            <a:p>
+              <a:pPr indent="0" lvl="0" marL="0" rtl="0" algn="l">
+                <a:spcBef>
+                  <a:spcPts val="0"/>
+                </a:spcBef>
+                <a:spcAft>
+                  <a:spcPts val="0"/>
+                </a:spcAft>
+                <a:buNone/>
+              </a:pPr>
+              <a:r>
+                <a:rPr b="1" lang="en-US" sz="1600">
+                  <a:solidFill>
+                    <a:srgbClr val="38BDF8"/>
+                  </a:solidFill>
+                  <a:latin typeface="Montserrat"/>
+                  <a:ea typeface="Montserrat"/>
+                  <a:cs typeface="Montserrat"/>
+                  <a:sym typeface="Montserrat"/>
+                </a:rPr>
+                <a:t>FinOps &amp; Budget</a:t>
+              </a:r>
+              <a:endParaRPr b="1" sz="1600">
+                <a:solidFill>
+                  <a:srgbClr val="38BDF8"/>
+                </a:solidFill>
+                <a:latin typeface="Montserrat"/>
+                <a:ea typeface="Montserrat"/>
+                <a:cs typeface="Montserrat"/>
+                <a:sym typeface="Montserrat"/>
+              </a:endParaRPr>
+            </a:p>
+            <a:p>
+              <a:pPr indent="0" lvl="0" marL="0" rtl="0" algn="l">
+                <a:spcBef>
+                  <a:spcPts val="225"/>
+                </a:spcBef>
+                <a:spcAft>
+                  <a:spcPts val="0"/>
+                </a:spcAft>
+                <a:buNone/>
+              </a:pPr>
+              <a:r>
+                <a:rPr b="0" lang="en-US">
+                  <a:solidFill>
+                    <a:srgbClr val="CBD5E1"/>
+                  </a:solidFill>
+                  <a:latin typeface="Montserrat"/>
+                  <a:ea typeface="Montserrat"/>
+                  <a:cs typeface="Montserrat"/>
+                  <a:sym typeface="Montserrat"/>
+                </a:rPr>
+                <a:t>Fine-tuning LoRA ~15$ sur GPU AWS A10G ; cache vectoriel (&lt; 1 200 €/an).</a:t>
+              </a:r>
+              <a:endParaRPr b="0">
+                <a:solidFill>
+                  <a:srgbClr val="CBD5E1"/>
+                </a:solidFill>
+                <a:latin typeface="Montserrat"/>
+                <a:ea typeface="Montserrat"/>
+                <a:cs typeface="Montserrat"/>
+                <a:sym typeface="Montserrat"/>
+              </a:endParaRPr>
+            </a:p>
+            <a:p>
+              <a:pPr indent="0" lvl="0" marL="0" rtl="0" algn="l">
+                <a:spcBef>
+                  <a:spcPts val="0"/>
+                </a:spcBef>
+                <a:spcAft>
+                  <a:spcPts val="0"/>
+                </a:spcAft>
+                <a:buNone/>
+              </a:pPr>
+              <a:r>
+                <a:rPr b="1" lang="en-US" sz="1600">
+                  <a:solidFill>
+                    <a:srgbClr val="38BDF8"/>
+                  </a:solidFill>
+                  <a:latin typeface="Montserrat"/>
+                  <a:ea typeface="Montserrat"/>
+                  <a:cs typeface="Montserrat"/>
+                  <a:sym typeface="Montserrat"/>
+                </a:rPr>
+                <a:t>Planning (6 mois)</a:t>
+              </a:r>
+              <a:endParaRPr b="1" sz="1600">
+                <a:solidFill>
+                  <a:srgbClr val="38BDF8"/>
+                </a:solidFill>
+                <a:latin typeface="Montserrat"/>
+                <a:ea typeface="Montserrat"/>
+                <a:cs typeface="Montserrat"/>
+                <a:sym typeface="Montserrat"/>
+              </a:endParaRPr>
+            </a:p>
+            <a:p>
+              <a:pPr indent="0" lvl="0" marL="0" rtl="0" algn="l">
+                <a:spcBef>
+                  <a:spcPts val="225"/>
+                </a:spcBef>
+                <a:spcAft>
+                  <a:spcPts val="0"/>
+                </a:spcAft>
+                <a:buNone/>
+              </a:pPr>
+              <a:r>
+                <a:rPr b="0" lang="en-US" sz="1350">
+                  <a:solidFill>
+                    <a:srgbClr val="F1F5F9"/>
+                  </a:solidFill>
+                  <a:latin typeface="Montserrat SemiBold"/>
+                  <a:ea typeface="Montserrat SemiBold"/>
+                  <a:cs typeface="Montserrat SemiBold"/>
+                  <a:sym typeface="Montserrat SemiBold"/>
+                </a:rPr>
+                <a:t>M1-M2:</a:t>
+              </a:r>
+              <a:r>
+                <a:rPr b="0" lang="en-US" sz="1350">
+                  <a:solidFill>
+                    <a:srgbClr val="CBD5E1"/>
+                  </a:solidFill>
+                  <a:latin typeface="Montserrat"/>
+                  <a:ea typeface="Montserrat"/>
+                  <a:cs typeface="Montserrat"/>
+                  <a:sym typeface="Montserrat"/>
+                </a:rPr>
+                <a:t> Scraping &amp; Gold Standard</a:t>
+              </a:r>
+              <a:br>
+                <a:rPr b="0" lang="en-US" sz="1350">
+                  <a:solidFill>
+                    <a:srgbClr val="CBD5E1"/>
+                  </a:solidFill>
+                  <a:latin typeface="Montserrat"/>
+                  <a:ea typeface="Montserrat"/>
+                  <a:cs typeface="Montserrat"/>
+                  <a:sym typeface="Montserrat"/>
+                </a:rPr>
+              </a:br>
+              <a:r>
+                <a:rPr b="0" lang="en-US" sz="1350">
+                  <a:solidFill>
+                    <a:srgbClr val="F1F5F9"/>
+                  </a:solidFill>
+                  <a:latin typeface="Montserrat SemiBold"/>
+                  <a:ea typeface="Montserrat SemiBold"/>
+                  <a:cs typeface="Montserrat SemiBold"/>
+                  <a:sym typeface="Montserrat SemiBold"/>
+                </a:rPr>
+                <a:t>M3-M4:</a:t>
+              </a:r>
+              <a:r>
+                <a:rPr b="0" lang="en-US" sz="1350">
+                  <a:solidFill>
+                    <a:srgbClr val="CBD5E1"/>
+                  </a:solidFill>
+                  <a:latin typeface="Montserrat"/>
+                  <a:ea typeface="Montserrat"/>
+                  <a:cs typeface="Montserrat"/>
+                  <a:sym typeface="Montserrat"/>
+                </a:rPr>
+                <a:t> Fine-tuning LoRA &amp; vLLM</a:t>
+              </a:r>
+              <a:br>
+                <a:rPr b="0" lang="en-US" sz="1350">
+                  <a:solidFill>
+                    <a:srgbClr val="CBD5E1"/>
+                  </a:solidFill>
+                  <a:latin typeface="Montserrat"/>
+                  <a:ea typeface="Montserrat"/>
+                  <a:cs typeface="Montserrat"/>
+                  <a:sym typeface="Montserrat"/>
+                </a:rPr>
+              </a:br>
+              <a:r>
+                <a:rPr b="0" lang="en-US" sz="1350">
+                  <a:solidFill>
+                    <a:srgbClr val="F1F5F9"/>
+                  </a:solidFill>
+                  <a:latin typeface="Montserrat SemiBold"/>
+                  <a:ea typeface="Montserrat SemiBold"/>
+                  <a:cs typeface="Montserrat SemiBold"/>
+                  <a:sym typeface="Montserrat SemiBold"/>
+                </a:rPr>
+                <a:t>M5-M6:</a:t>
+              </a:r>
+              <a:r>
+                <a:rPr b="0" lang="en-US" sz="1350">
+                  <a:solidFill>
+                    <a:srgbClr val="CBD5E1"/>
+                  </a:solidFill>
+                  <a:latin typeface="Montserrat"/>
+                  <a:ea typeface="Montserrat"/>
+                  <a:cs typeface="Montserrat"/>
+                  <a:sym typeface="Montserrat"/>
+                </a:rPr>
+                <a:t> MLflow &amp; Monitoring</a:t>
+              </a:r>
+              <a:endParaRPr b="0" sz="1350">
+                <a:solidFill>
+                  <a:srgbClr val="CBD5E1"/>
+                </a:solidFill>
+                <a:latin typeface="Montserrat"/>
+                <a:ea typeface="Montserrat"/>
+                <a:cs typeface="Montserrat"/>
+                <a:sym typeface="Montserrat"/>
+              </a:endParaRPr>
+            </a:p>
+          </p:txBody>
+        </p:sp>
       </p:grpSp>
     </p:spTree>
   </p:cSld>
@@ -17612,7 +18054,7 @@
             <a:tbl>
               <a:tblPr bandRow="1" firstRow="1">
                 <a:noFill/>
-                <a:tableStyleId>{5D8E7B14-1A53-479F-AF55-B245E0A7D556}</a:tableStyleId>
+                <a:tableStyleId>{E64BBE99-929C-4C64-93E3-419B028FC6D0}</a:tableStyleId>
               </a:tblPr>
               <a:tblGrid>
                 <a:gridCol w="3291850"/>

</xml_diff>